<commit_message>
Publish validated pruning, distillation and CPU GPU study
</commit_message>
<xml_diff>
--- a/presentation/Pruning_Under_8GiB_Level4.pptx
+++ b/presentation/Pruning_Under_8GiB_Level4.pptx
@@ -201,7 +201,7 @@
             </a:lvl1pPr>
           </a:lstStyle>
           <a:p>
-            <a:fld id="{DF29590C-AFCC-47F8-886C-F8EBD1786F20}" type="datetimeFigureOut">
+            <a:fld id="{14A5F31E-F741-4C50-8001-506643A635B5}" type="datetimeFigureOut">
               <a:rPr lang="en-150" smtClean="0"/>
               <a:t>26/10/2026</a:t>
             </a:fld>
@@ -360,7 +360,7 @@
             </a:lvl1pPr>
           </a:lstStyle>
           <a:p>
-            <a:fld id="{83F5D92A-D26D-4C98-AA10-B3337C3FCBE0}" type="slidenum">
+            <a:fld id="{CEAE3E1F-B221-4FE3-83F3-297ED33C9031}" type="slidenum">
               <a:rPr lang="en-150" smtClean="0"/>
               <a:t>‹#›</a:t>
             </a:fld>
@@ -371,7 +371,7 @@
     </p:spTree>
     <p:extLst>
       <p:ext uri="{BB962C8B-B14F-4D97-AF65-F5344CB8AC3E}">
-        <p14:creationId xmlns:p14="http://schemas.microsoft.com/office/powerpoint/2010/main" val="13613954"/>
+        <p14:creationId xmlns:p14="http://schemas.microsoft.com/office/powerpoint/2010/main" val="1232238107"/>
       </p:ext>
     </p:extLst>
   </p:cSld>
@@ -538,7 +538,7 @@
           <a:bodyPr/>
           <a:lstStyle/>
           <a:p>
-            <a:fld id="{83F5D92A-D26D-4C98-AA10-B3337C3FCBE0}" type="slidenum">
+            <a:fld id="{CEAE3E1F-B221-4FE3-83F3-297ED33C9031}" type="slidenum">
               <a:rPr lang="en-150" smtClean="0"/>
               <a:t>1</a:t>
             </a:fld>
@@ -549,7 +549,7 @@
     </p:spTree>
     <p:extLst>
       <p:ext uri="{BB962C8B-B14F-4D97-AF65-F5344CB8AC3E}">
-        <p14:creationId xmlns:p14="http://schemas.microsoft.com/office/powerpoint/2010/main" val="3712462148"/>
+        <p14:creationId xmlns:p14="http://schemas.microsoft.com/office/powerpoint/2010/main" val="3175707591"/>
       </p:ext>
     </p:extLst>
   </p:cSld>
@@ -626,7 +626,7 @@
           <a:bodyPr/>
           <a:lstStyle/>
           <a:p>
-            <a:fld id="{83F5D92A-D26D-4C98-AA10-B3337C3FCBE0}" type="slidenum">
+            <a:fld id="{CEAE3E1F-B221-4FE3-83F3-297ED33C9031}" type="slidenum">
               <a:rPr lang="en-150" smtClean="0"/>
               <a:t>10</a:t>
             </a:fld>
@@ -637,7 +637,7 @@
     </p:spTree>
     <p:extLst>
       <p:ext uri="{BB962C8B-B14F-4D97-AF65-F5344CB8AC3E}">
-        <p14:creationId xmlns:p14="http://schemas.microsoft.com/office/powerpoint/2010/main" val="4175312121"/>
+        <p14:creationId xmlns:p14="http://schemas.microsoft.com/office/powerpoint/2010/main" val="3617774886"/>
       </p:ext>
     </p:extLst>
   </p:cSld>
@@ -714,7 +714,7 @@
           <a:bodyPr/>
           <a:lstStyle/>
           <a:p>
-            <a:fld id="{83F5D92A-D26D-4C98-AA10-B3337C3FCBE0}" type="slidenum">
+            <a:fld id="{CEAE3E1F-B221-4FE3-83F3-297ED33C9031}" type="slidenum">
               <a:rPr lang="en-150" smtClean="0"/>
               <a:t>11</a:t>
             </a:fld>
@@ -725,7 +725,7 @@
     </p:spTree>
     <p:extLst>
       <p:ext uri="{BB962C8B-B14F-4D97-AF65-F5344CB8AC3E}">
-        <p14:creationId xmlns:p14="http://schemas.microsoft.com/office/powerpoint/2010/main" val="848651938"/>
+        <p14:creationId xmlns:p14="http://schemas.microsoft.com/office/powerpoint/2010/main" val="4013186677"/>
       </p:ext>
     </p:extLst>
   </p:cSld>
@@ -802,7 +802,7 @@
           <a:bodyPr/>
           <a:lstStyle/>
           <a:p>
-            <a:fld id="{83F5D92A-D26D-4C98-AA10-B3337C3FCBE0}" type="slidenum">
+            <a:fld id="{CEAE3E1F-B221-4FE3-83F3-297ED33C9031}" type="slidenum">
               <a:rPr lang="en-150" smtClean="0"/>
               <a:t>12</a:t>
             </a:fld>
@@ -813,7 +813,7 @@
     </p:spTree>
     <p:extLst>
       <p:ext uri="{BB962C8B-B14F-4D97-AF65-F5344CB8AC3E}">
-        <p14:creationId xmlns:p14="http://schemas.microsoft.com/office/powerpoint/2010/main" val="3271850397"/>
+        <p14:creationId xmlns:p14="http://schemas.microsoft.com/office/powerpoint/2010/main" val="1361980291"/>
       </p:ext>
     </p:extLst>
   </p:cSld>
@@ -890,7 +890,7 @@
           <a:bodyPr/>
           <a:lstStyle/>
           <a:p>
-            <a:fld id="{83F5D92A-D26D-4C98-AA10-B3337C3FCBE0}" type="slidenum">
+            <a:fld id="{CEAE3E1F-B221-4FE3-83F3-297ED33C9031}" type="slidenum">
               <a:rPr lang="en-150" smtClean="0"/>
               <a:t>2</a:t>
             </a:fld>
@@ -901,7 +901,7 @@
     </p:spTree>
     <p:extLst>
       <p:ext uri="{BB962C8B-B14F-4D97-AF65-F5344CB8AC3E}">
-        <p14:creationId xmlns:p14="http://schemas.microsoft.com/office/powerpoint/2010/main" val="189393425"/>
+        <p14:creationId xmlns:p14="http://schemas.microsoft.com/office/powerpoint/2010/main" val="988668977"/>
       </p:ext>
     </p:extLst>
   </p:cSld>
@@ -978,7 +978,7 @@
           <a:bodyPr/>
           <a:lstStyle/>
           <a:p>
-            <a:fld id="{83F5D92A-D26D-4C98-AA10-B3337C3FCBE0}" type="slidenum">
+            <a:fld id="{CEAE3E1F-B221-4FE3-83F3-297ED33C9031}" type="slidenum">
               <a:rPr lang="en-150" smtClean="0"/>
               <a:t>3</a:t>
             </a:fld>
@@ -989,7 +989,7 @@
     </p:spTree>
     <p:extLst>
       <p:ext uri="{BB962C8B-B14F-4D97-AF65-F5344CB8AC3E}">
-        <p14:creationId xmlns:p14="http://schemas.microsoft.com/office/powerpoint/2010/main" val="3402445192"/>
+        <p14:creationId xmlns:p14="http://schemas.microsoft.com/office/powerpoint/2010/main" val="2114891045"/>
       </p:ext>
     </p:extLst>
   </p:cSld>
@@ -1066,7 +1066,7 @@
           <a:bodyPr/>
           <a:lstStyle/>
           <a:p>
-            <a:fld id="{83F5D92A-D26D-4C98-AA10-B3337C3FCBE0}" type="slidenum">
+            <a:fld id="{CEAE3E1F-B221-4FE3-83F3-297ED33C9031}" type="slidenum">
               <a:rPr lang="en-150" smtClean="0"/>
               <a:t>4</a:t>
             </a:fld>
@@ -1077,7 +1077,7 @@
     </p:spTree>
     <p:extLst>
       <p:ext uri="{BB962C8B-B14F-4D97-AF65-F5344CB8AC3E}">
-        <p14:creationId xmlns:p14="http://schemas.microsoft.com/office/powerpoint/2010/main" val="3554406441"/>
+        <p14:creationId xmlns:p14="http://schemas.microsoft.com/office/powerpoint/2010/main" val="1675765556"/>
       </p:ext>
     </p:extLst>
   </p:cSld>
@@ -1154,7 +1154,7 @@
           <a:bodyPr/>
           <a:lstStyle/>
           <a:p>
-            <a:fld id="{83F5D92A-D26D-4C98-AA10-B3337C3FCBE0}" type="slidenum">
+            <a:fld id="{CEAE3E1F-B221-4FE3-83F3-297ED33C9031}" type="slidenum">
               <a:rPr lang="en-150" smtClean="0"/>
               <a:t>5</a:t>
             </a:fld>
@@ -1165,7 +1165,7 @@
     </p:spTree>
     <p:extLst>
       <p:ext uri="{BB962C8B-B14F-4D97-AF65-F5344CB8AC3E}">
-        <p14:creationId xmlns:p14="http://schemas.microsoft.com/office/powerpoint/2010/main" val="3529235667"/>
+        <p14:creationId xmlns:p14="http://schemas.microsoft.com/office/powerpoint/2010/main" val="3723324282"/>
       </p:ext>
     </p:extLst>
   </p:cSld>
@@ -1242,7 +1242,7 @@
           <a:bodyPr/>
           <a:lstStyle/>
           <a:p>
-            <a:fld id="{83F5D92A-D26D-4C98-AA10-B3337C3FCBE0}" type="slidenum">
+            <a:fld id="{CEAE3E1F-B221-4FE3-83F3-297ED33C9031}" type="slidenum">
               <a:rPr lang="en-150" smtClean="0"/>
               <a:t>6</a:t>
             </a:fld>
@@ -1253,7 +1253,7 @@
     </p:spTree>
     <p:extLst>
       <p:ext uri="{BB962C8B-B14F-4D97-AF65-F5344CB8AC3E}">
-        <p14:creationId xmlns:p14="http://schemas.microsoft.com/office/powerpoint/2010/main" val="2151785971"/>
+        <p14:creationId xmlns:p14="http://schemas.microsoft.com/office/powerpoint/2010/main" val="1657058589"/>
       </p:ext>
     </p:extLst>
   </p:cSld>
@@ -1330,7 +1330,7 @@
           <a:bodyPr/>
           <a:lstStyle/>
           <a:p>
-            <a:fld id="{83F5D92A-D26D-4C98-AA10-B3337C3FCBE0}" type="slidenum">
+            <a:fld id="{CEAE3E1F-B221-4FE3-83F3-297ED33C9031}" type="slidenum">
               <a:rPr lang="en-150" smtClean="0"/>
               <a:t>7</a:t>
             </a:fld>
@@ -1341,7 +1341,7 @@
     </p:spTree>
     <p:extLst>
       <p:ext uri="{BB962C8B-B14F-4D97-AF65-F5344CB8AC3E}">
-        <p14:creationId xmlns:p14="http://schemas.microsoft.com/office/powerpoint/2010/main" val="3486609960"/>
+        <p14:creationId xmlns:p14="http://schemas.microsoft.com/office/powerpoint/2010/main" val="124366313"/>
       </p:ext>
     </p:extLst>
   </p:cSld>
@@ -1418,7 +1418,7 @@
           <a:bodyPr/>
           <a:lstStyle/>
           <a:p>
-            <a:fld id="{83F5D92A-D26D-4C98-AA10-B3337C3FCBE0}" type="slidenum">
+            <a:fld id="{CEAE3E1F-B221-4FE3-83F3-297ED33C9031}" type="slidenum">
               <a:rPr lang="en-150" smtClean="0"/>
               <a:t>8</a:t>
             </a:fld>
@@ -1429,7 +1429,7 @@
     </p:spTree>
     <p:extLst>
       <p:ext uri="{BB962C8B-B14F-4D97-AF65-F5344CB8AC3E}">
-        <p14:creationId xmlns:p14="http://schemas.microsoft.com/office/powerpoint/2010/main" val="33688687"/>
+        <p14:creationId xmlns:p14="http://schemas.microsoft.com/office/powerpoint/2010/main" val="2206707512"/>
       </p:ext>
     </p:extLst>
   </p:cSld>
@@ -1506,7 +1506,7 @@
           <a:bodyPr/>
           <a:lstStyle/>
           <a:p>
-            <a:fld id="{83F5D92A-D26D-4C98-AA10-B3337C3FCBE0}" type="slidenum">
+            <a:fld id="{CEAE3E1F-B221-4FE3-83F3-297ED33C9031}" type="slidenum">
               <a:rPr lang="en-150" smtClean="0"/>
               <a:t>9</a:t>
             </a:fld>
@@ -1517,7 +1517,7 @@
     </p:spTree>
     <p:extLst>
       <p:ext uri="{BB962C8B-B14F-4D97-AF65-F5344CB8AC3E}">
-        <p14:creationId xmlns:p14="http://schemas.microsoft.com/office/powerpoint/2010/main" val="432711949"/>
+        <p14:creationId xmlns:p14="http://schemas.microsoft.com/office/powerpoint/2010/main" val="3907401551"/>
       </p:ext>
     </p:extLst>
   </p:cSld>
@@ -1549,7 +1549,7 @@
           <p:cNvPr id="2" name="Title 1">
             <a:extLst>
               <a:ext uri="{FF2B5EF4-FFF2-40B4-BE49-F238E27FC236}">
-                <a16:creationId xmlns:a16="http://schemas.microsoft.com/office/drawing/2014/main" id="{D8C3C5BF-81FF-B659-4558-2641C9024D43}"/>
+                <a16:creationId xmlns:a16="http://schemas.microsoft.com/office/drawing/2014/main" id="{5A9EEBD3-E76E-0DC4-7048-E13B69D94E41}"/>
               </a:ext>
             </a:extLst>
           </p:cNvPr>
@@ -1587,7 +1587,7 @@
           <p:cNvPr id="3" name="Subtitle 2">
             <a:extLst>
               <a:ext uri="{FF2B5EF4-FFF2-40B4-BE49-F238E27FC236}">
-                <a16:creationId xmlns:a16="http://schemas.microsoft.com/office/drawing/2014/main" id="{05633371-7806-0AC4-4F5F-89C5E85F2C46}"/>
+                <a16:creationId xmlns:a16="http://schemas.microsoft.com/office/drawing/2014/main" id="{1903E3A1-1F0E-1CFE-0040-2B556673C164}"/>
               </a:ext>
             </a:extLst>
           </p:cNvPr>
@@ -1658,7 +1658,7 @@
           <p:cNvPr id="4" name="Date Placeholder 3">
             <a:extLst>
               <a:ext uri="{FF2B5EF4-FFF2-40B4-BE49-F238E27FC236}">
-                <a16:creationId xmlns:a16="http://schemas.microsoft.com/office/drawing/2014/main" id="{4389C290-25BA-2B97-65ED-886F9451ACCB}"/>
+                <a16:creationId xmlns:a16="http://schemas.microsoft.com/office/drawing/2014/main" id="{5890EBD3-8F6D-42D8-416E-39BD923DB389}"/>
               </a:ext>
             </a:extLst>
           </p:cNvPr>
@@ -1674,7 +1674,7 @@
           <a:bodyPr/>
           <a:lstStyle/>
           <a:p>
-            <a:fld id="{28A79F54-38CD-430F-B2A3-583392FA0233}" type="datetimeFigureOut">
+            <a:fld id="{7E5F07D2-0123-4E0E-8F81-2812B80D41D9}" type="datetimeFigureOut">
               <a:rPr lang="en-150" smtClean="0"/>
               <a:t>26/10/2026</a:t>
             </a:fld>
@@ -1687,7 +1687,7 @@
           <p:cNvPr id="5" name="Footer Placeholder 4">
             <a:extLst>
               <a:ext uri="{FF2B5EF4-FFF2-40B4-BE49-F238E27FC236}">
-                <a16:creationId xmlns:a16="http://schemas.microsoft.com/office/drawing/2014/main" id="{118F317C-28A7-3595-CEAD-AF40FB77404F}"/>
+                <a16:creationId xmlns:a16="http://schemas.microsoft.com/office/drawing/2014/main" id="{9019ADDD-526D-02F7-9023-F9E2E92975BB}"/>
               </a:ext>
             </a:extLst>
           </p:cNvPr>
@@ -1712,7 +1712,7 @@
           <p:cNvPr id="6" name="Slide Number Placeholder 5">
             <a:extLst>
               <a:ext uri="{FF2B5EF4-FFF2-40B4-BE49-F238E27FC236}">
-                <a16:creationId xmlns:a16="http://schemas.microsoft.com/office/drawing/2014/main" id="{72A7E80F-D910-83C8-6E53-C695E1873264}"/>
+                <a16:creationId xmlns:a16="http://schemas.microsoft.com/office/drawing/2014/main" id="{A85AC3AB-8B88-286D-B722-3CFF2659F1ED}"/>
               </a:ext>
             </a:extLst>
           </p:cNvPr>
@@ -1728,7 +1728,7 @@
           <a:bodyPr/>
           <a:lstStyle/>
           <a:p>
-            <a:fld id="{483134EA-AF8E-4025-9293-54B9F96F6B5B}" type="slidenum">
+            <a:fld id="{908A8051-4A3C-4A59-A03A-228B1FECC8A9}" type="slidenum">
               <a:rPr lang="en-150" smtClean="0"/>
               <a:t>‹#›</a:t>
             </a:fld>
@@ -1739,7 +1739,7 @@
     </p:spTree>
     <p:extLst>
       <p:ext uri="{BB962C8B-B14F-4D97-AF65-F5344CB8AC3E}">
-        <p14:creationId xmlns:p14="http://schemas.microsoft.com/office/powerpoint/2010/main" val="633802095"/>
+        <p14:creationId xmlns:p14="http://schemas.microsoft.com/office/powerpoint/2010/main" val="2296393954"/>
       </p:ext>
     </p:extLst>
   </p:cSld>
@@ -1771,7 +1771,7 @@
           <p:cNvPr id="2" name="Title 1">
             <a:extLst>
               <a:ext uri="{FF2B5EF4-FFF2-40B4-BE49-F238E27FC236}">
-                <a16:creationId xmlns:a16="http://schemas.microsoft.com/office/drawing/2014/main" id="{C247E981-FE14-55CA-2918-91E7ED6BA029}"/>
+                <a16:creationId xmlns:a16="http://schemas.microsoft.com/office/drawing/2014/main" id="{DEFCA8E3-B3A0-8340-8FCA-5282E5DEBDBC}"/>
               </a:ext>
             </a:extLst>
           </p:cNvPr>
@@ -1800,7 +1800,7 @@
           <p:cNvPr id="3" name="Vertical Text Placeholder 2">
             <a:extLst>
               <a:ext uri="{FF2B5EF4-FFF2-40B4-BE49-F238E27FC236}">
-                <a16:creationId xmlns:a16="http://schemas.microsoft.com/office/drawing/2014/main" id="{824AAAC7-87D3-F719-7C31-FF0B933F2867}"/>
+                <a16:creationId xmlns:a16="http://schemas.microsoft.com/office/drawing/2014/main" id="{52D1AAD9-3EF0-EC28-8462-C57489648036}"/>
               </a:ext>
             </a:extLst>
           </p:cNvPr>
@@ -1858,7 +1858,7 @@
           <p:cNvPr id="4" name="Date Placeholder 3">
             <a:extLst>
               <a:ext uri="{FF2B5EF4-FFF2-40B4-BE49-F238E27FC236}">
-                <a16:creationId xmlns:a16="http://schemas.microsoft.com/office/drawing/2014/main" id="{B4AEFB57-6A7C-C404-DB7D-E99174A8347D}"/>
+                <a16:creationId xmlns:a16="http://schemas.microsoft.com/office/drawing/2014/main" id="{DA459C60-473E-9D42-27B8-12AF59B9EAF3}"/>
               </a:ext>
             </a:extLst>
           </p:cNvPr>
@@ -1874,7 +1874,7 @@
           <a:bodyPr/>
           <a:lstStyle/>
           <a:p>
-            <a:fld id="{28A79F54-38CD-430F-B2A3-583392FA0233}" type="datetimeFigureOut">
+            <a:fld id="{7E5F07D2-0123-4E0E-8F81-2812B80D41D9}" type="datetimeFigureOut">
               <a:rPr lang="en-150" smtClean="0"/>
               <a:t>26/10/2026</a:t>
             </a:fld>
@@ -1887,7 +1887,7 @@
           <p:cNvPr id="5" name="Footer Placeholder 4">
             <a:extLst>
               <a:ext uri="{FF2B5EF4-FFF2-40B4-BE49-F238E27FC236}">
-                <a16:creationId xmlns:a16="http://schemas.microsoft.com/office/drawing/2014/main" id="{219AB49E-3C32-5573-74DE-FDAF344F0D8C}"/>
+                <a16:creationId xmlns:a16="http://schemas.microsoft.com/office/drawing/2014/main" id="{E1F7CA06-8ACD-A511-30DF-9E79E6B64269}"/>
               </a:ext>
             </a:extLst>
           </p:cNvPr>
@@ -1912,7 +1912,7 @@
           <p:cNvPr id="6" name="Slide Number Placeholder 5">
             <a:extLst>
               <a:ext uri="{FF2B5EF4-FFF2-40B4-BE49-F238E27FC236}">
-                <a16:creationId xmlns:a16="http://schemas.microsoft.com/office/drawing/2014/main" id="{29BD61E7-7CA3-E79A-0D55-1E574B860682}"/>
+                <a16:creationId xmlns:a16="http://schemas.microsoft.com/office/drawing/2014/main" id="{F6C33A5A-140F-93BB-0D8B-5775B992893A}"/>
               </a:ext>
             </a:extLst>
           </p:cNvPr>
@@ -1928,7 +1928,7 @@
           <a:bodyPr/>
           <a:lstStyle/>
           <a:p>
-            <a:fld id="{483134EA-AF8E-4025-9293-54B9F96F6B5B}" type="slidenum">
+            <a:fld id="{908A8051-4A3C-4A59-A03A-228B1FECC8A9}" type="slidenum">
               <a:rPr lang="en-150" smtClean="0"/>
               <a:t>‹#›</a:t>
             </a:fld>
@@ -1939,7 +1939,7 @@
     </p:spTree>
     <p:extLst>
       <p:ext uri="{BB962C8B-B14F-4D97-AF65-F5344CB8AC3E}">
-        <p14:creationId xmlns:p14="http://schemas.microsoft.com/office/powerpoint/2010/main" val="2182112183"/>
+        <p14:creationId xmlns:p14="http://schemas.microsoft.com/office/powerpoint/2010/main" val="1396127819"/>
       </p:ext>
     </p:extLst>
   </p:cSld>
@@ -1971,7 +1971,7 @@
           <p:cNvPr id="2" name="Vertical Title 1">
             <a:extLst>
               <a:ext uri="{FF2B5EF4-FFF2-40B4-BE49-F238E27FC236}">
-                <a16:creationId xmlns:a16="http://schemas.microsoft.com/office/drawing/2014/main" id="{6A4A3C25-0309-BAD1-E7A5-B31343968CDC}"/>
+                <a16:creationId xmlns:a16="http://schemas.microsoft.com/office/drawing/2014/main" id="{5A2725C0-3D3A-9175-4A2F-7A3884F6BFF6}"/>
               </a:ext>
             </a:extLst>
           </p:cNvPr>
@@ -2005,7 +2005,7 @@
           <p:cNvPr id="3" name="Vertical Text Placeholder 2">
             <a:extLst>
               <a:ext uri="{FF2B5EF4-FFF2-40B4-BE49-F238E27FC236}">
-                <a16:creationId xmlns:a16="http://schemas.microsoft.com/office/drawing/2014/main" id="{5F227ED7-DBE4-0244-8490-3CD3348D43F2}"/>
+                <a16:creationId xmlns:a16="http://schemas.microsoft.com/office/drawing/2014/main" id="{DDD1D898-A583-07DF-B21A-6B89D26F1022}"/>
               </a:ext>
             </a:extLst>
           </p:cNvPr>
@@ -2068,7 +2068,7 @@
           <p:cNvPr id="4" name="Date Placeholder 3">
             <a:extLst>
               <a:ext uri="{FF2B5EF4-FFF2-40B4-BE49-F238E27FC236}">
-                <a16:creationId xmlns:a16="http://schemas.microsoft.com/office/drawing/2014/main" id="{6E1E0F44-5903-82B9-15C3-EF8C3B7C11EB}"/>
+                <a16:creationId xmlns:a16="http://schemas.microsoft.com/office/drawing/2014/main" id="{DEAF5558-BBA6-ACC7-7BB1-1319DC550558}"/>
               </a:ext>
             </a:extLst>
           </p:cNvPr>
@@ -2084,7 +2084,7 @@
           <a:bodyPr/>
           <a:lstStyle/>
           <a:p>
-            <a:fld id="{28A79F54-38CD-430F-B2A3-583392FA0233}" type="datetimeFigureOut">
+            <a:fld id="{7E5F07D2-0123-4E0E-8F81-2812B80D41D9}" type="datetimeFigureOut">
               <a:rPr lang="en-150" smtClean="0"/>
               <a:t>26/10/2026</a:t>
             </a:fld>
@@ -2097,7 +2097,7 @@
           <p:cNvPr id="5" name="Footer Placeholder 4">
             <a:extLst>
               <a:ext uri="{FF2B5EF4-FFF2-40B4-BE49-F238E27FC236}">
-                <a16:creationId xmlns:a16="http://schemas.microsoft.com/office/drawing/2014/main" id="{B020670C-DA88-A803-6D06-7540E1F59C83}"/>
+                <a16:creationId xmlns:a16="http://schemas.microsoft.com/office/drawing/2014/main" id="{BF54439C-1D1B-DED1-8B53-77AA629B7B21}"/>
               </a:ext>
             </a:extLst>
           </p:cNvPr>
@@ -2122,7 +2122,7 @@
           <p:cNvPr id="6" name="Slide Number Placeholder 5">
             <a:extLst>
               <a:ext uri="{FF2B5EF4-FFF2-40B4-BE49-F238E27FC236}">
-                <a16:creationId xmlns:a16="http://schemas.microsoft.com/office/drawing/2014/main" id="{8D8318DC-96FB-B76E-07DB-EDF245B561BC}"/>
+                <a16:creationId xmlns:a16="http://schemas.microsoft.com/office/drawing/2014/main" id="{BABAC729-320A-52A0-2D42-28373EC67B64}"/>
               </a:ext>
             </a:extLst>
           </p:cNvPr>
@@ -2138,7 +2138,7 @@
           <a:bodyPr/>
           <a:lstStyle/>
           <a:p>
-            <a:fld id="{483134EA-AF8E-4025-9293-54B9F96F6B5B}" type="slidenum">
+            <a:fld id="{908A8051-4A3C-4A59-A03A-228B1FECC8A9}" type="slidenum">
               <a:rPr lang="en-150" smtClean="0"/>
               <a:t>‹#›</a:t>
             </a:fld>
@@ -2149,7 +2149,7 @@
     </p:spTree>
     <p:extLst>
       <p:ext uri="{BB962C8B-B14F-4D97-AF65-F5344CB8AC3E}">
-        <p14:creationId xmlns:p14="http://schemas.microsoft.com/office/powerpoint/2010/main" val="3405506020"/>
+        <p14:creationId xmlns:p14="http://schemas.microsoft.com/office/powerpoint/2010/main" val="2911459728"/>
       </p:ext>
     </p:extLst>
   </p:cSld>
@@ -2181,7 +2181,7 @@
           <p:cNvPr id="2" name="Title 1">
             <a:extLst>
               <a:ext uri="{FF2B5EF4-FFF2-40B4-BE49-F238E27FC236}">
-                <a16:creationId xmlns:a16="http://schemas.microsoft.com/office/drawing/2014/main" id="{B5D082E3-5870-EF83-075A-2ED0A993DCD0}"/>
+                <a16:creationId xmlns:a16="http://schemas.microsoft.com/office/drawing/2014/main" id="{B4C7AE67-5AD0-C823-1D73-6FD0752E197D}"/>
               </a:ext>
             </a:extLst>
           </p:cNvPr>
@@ -2210,7 +2210,7 @@
           <p:cNvPr id="3" name="Content Placeholder 2">
             <a:extLst>
               <a:ext uri="{FF2B5EF4-FFF2-40B4-BE49-F238E27FC236}">
-                <a16:creationId xmlns:a16="http://schemas.microsoft.com/office/drawing/2014/main" id="{4F378E0C-7BE5-EE4B-8C99-274D5D7D3B9D}"/>
+                <a16:creationId xmlns:a16="http://schemas.microsoft.com/office/drawing/2014/main" id="{EC0EE79E-1061-5684-0809-A63D1B446573}"/>
               </a:ext>
             </a:extLst>
           </p:cNvPr>
@@ -2268,7 +2268,7 @@
           <p:cNvPr id="4" name="Date Placeholder 3">
             <a:extLst>
               <a:ext uri="{FF2B5EF4-FFF2-40B4-BE49-F238E27FC236}">
-                <a16:creationId xmlns:a16="http://schemas.microsoft.com/office/drawing/2014/main" id="{55B66661-DA5E-E1FE-A4B9-EE7DF95C5086}"/>
+                <a16:creationId xmlns:a16="http://schemas.microsoft.com/office/drawing/2014/main" id="{9EEB9445-D350-F32B-CA8C-CBD507D36FE3}"/>
               </a:ext>
             </a:extLst>
           </p:cNvPr>
@@ -2284,7 +2284,7 @@
           <a:bodyPr/>
           <a:lstStyle/>
           <a:p>
-            <a:fld id="{28A79F54-38CD-430F-B2A3-583392FA0233}" type="datetimeFigureOut">
+            <a:fld id="{7E5F07D2-0123-4E0E-8F81-2812B80D41D9}" type="datetimeFigureOut">
               <a:rPr lang="en-150" smtClean="0"/>
               <a:t>26/10/2026</a:t>
             </a:fld>
@@ -2297,7 +2297,7 @@
           <p:cNvPr id="5" name="Footer Placeholder 4">
             <a:extLst>
               <a:ext uri="{FF2B5EF4-FFF2-40B4-BE49-F238E27FC236}">
-                <a16:creationId xmlns:a16="http://schemas.microsoft.com/office/drawing/2014/main" id="{C2B3A6B9-E6BA-22BE-7798-10D4BC6C5C38}"/>
+                <a16:creationId xmlns:a16="http://schemas.microsoft.com/office/drawing/2014/main" id="{9885349E-9872-BC66-D166-F5EB3A771BEF}"/>
               </a:ext>
             </a:extLst>
           </p:cNvPr>
@@ -2322,7 +2322,7 @@
           <p:cNvPr id="6" name="Slide Number Placeholder 5">
             <a:extLst>
               <a:ext uri="{FF2B5EF4-FFF2-40B4-BE49-F238E27FC236}">
-                <a16:creationId xmlns:a16="http://schemas.microsoft.com/office/drawing/2014/main" id="{248DAFA3-C686-6110-2064-74F5B8E5DB42}"/>
+                <a16:creationId xmlns:a16="http://schemas.microsoft.com/office/drawing/2014/main" id="{FAE448F1-F4E6-83BE-1F0F-8F07481D8A66}"/>
               </a:ext>
             </a:extLst>
           </p:cNvPr>
@@ -2338,7 +2338,7 @@
           <a:bodyPr/>
           <a:lstStyle/>
           <a:p>
-            <a:fld id="{483134EA-AF8E-4025-9293-54B9F96F6B5B}" type="slidenum">
+            <a:fld id="{908A8051-4A3C-4A59-A03A-228B1FECC8A9}" type="slidenum">
               <a:rPr lang="en-150" smtClean="0"/>
               <a:t>‹#›</a:t>
             </a:fld>
@@ -2349,7 +2349,7 @@
     </p:spTree>
     <p:extLst>
       <p:ext uri="{BB962C8B-B14F-4D97-AF65-F5344CB8AC3E}">
-        <p14:creationId xmlns:p14="http://schemas.microsoft.com/office/powerpoint/2010/main" val="3467824106"/>
+        <p14:creationId xmlns:p14="http://schemas.microsoft.com/office/powerpoint/2010/main" val="1251948098"/>
       </p:ext>
     </p:extLst>
   </p:cSld>
@@ -2381,7 +2381,7 @@
           <p:cNvPr id="2" name="Title 1">
             <a:extLst>
               <a:ext uri="{FF2B5EF4-FFF2-40B4-BE49-F238E27FC236}">
-                <a16:creationId xmlns:a16="http://schemas.microsoft.com/office/drawing/2014/main" id="{D8FAF591-2DB3-D2B4-74E9-93A49FEC21D1}"/>
+                <a16:creationId xmlns:a16="http://schemas.microsoft.com/office/drawing/2014/main" id="{3D502178-E485-3E31-9E51-D77382836B2E}"/>
               </a:ext>
             </a:extLst>
           </p:cNvPr>
@@ -2419,7 +2419,7 @@
           <p:cNvPr id="3" name="Text Placeholder 2">
             <a:extLst>
               <a:ext uri="{FF2B5EF4-FFF2-40B4-BE49-F238E27FC236}">
-                <a16:creationId xmlns:a16="http://schemas.microsoft.com/office/drawing/2014/main" id="{7803DEA2-F949-7439-FFBA-CA605FA2B14D}"/>
+                <a16:creationId xmlns:a16="http://schemas.microsoft.com/office/drawing/2014/main" id="{E0C48322-F7E2-7B41-243B-7466663CE563}"/>
               </a:ext>
             </a:extLst>
           </p:cNvPr>
@@ -2544,7 +2544,7 @@
           <p:cNvPr id="4" name="Date Placeholder 3">
             <a:extLst>
               <a:ext uri="{FF2B5EF4-FFF2-40B4-BE49-F238E27FC236}">
-                <a16:creationId xmlns:a16="http://schemas.microsoft.com/office/drawing/2014/main" id="{6D85A8F8-5B7A-A70A-E724-C4129A65EF51}"/>
+                <a16:creationId xmlns:a16="http://schemas.microsoft.com/office/drawing/2014/main" id="{7078F297-F194-4854-46E0-DC732BA79084}"/>
               </a:ext>
             </a:extLst>
           </p:cNvPr>
@@ -2560,7 +2560,7 @@
           <a:bodyPr/>
           <a:lstStyle/>
           <a:p>
-            <a:fld id="{28A79F54-38CD-430F-B2A3-583392FA0233}" type="datetimeFigureOut">
+            <a:fld id="{7E5F07D2-0123-4E0E-8F81-2812B80D41D9}" type="datetimeFigureOut">
               <a:rPr lang="en-150" smtClean="0"/>
               <a:t>26/10/2026</a:t>
             </a:fld>
@@ -2573,7 +2573,7 @@
           <p:cNvPr id="5" name="Footer Placeholder 4">
             <a:extLst>
               <a:ext uri="{FF2B5EF4-FFF2-40B4-BE49-F238E27FC236}">
-                <a16:creationId xmlns:a16="http://schemas.microsoft.com/office/drawing/2014/main" id="{C407D41B-49E7-2179-F1AC-3183812561A4}"/>
+                <a16:creationId xmlns:a16="http://schemas.microsoft.com/office/drawing/2014/main" id="{30D0E053-B1AE-5C5A-1FE8-6E1DFCF5CD38}"/>
               </a:ext>
             </a:extLst>
           </p:cNvPr>
@@ -2598,7 +2598,7 @@
           <p:cNvPr id="6" name="Slide Number Placeholder 5">
             <a:extLst>
               <a:ext uri="{FF2B5EF4-FFF2-40B4-BE49-F238E27FC236}">
-                <a16:creationId xmlns:a16="http://schemas.microsoft.com/office/drawing/2014/main" id="{6086962A-3C8A-0246-3FE8-B57DE3E37815}"/>
+                <a16:creationId xmlns:a16="http://schemas.microsoft.com/office/drawing/2014/main" id="{47604AB4-3E1D-79AE-B54E-58D67EEAD40A}"/>
               </a:ext>
             </a:extLst>
           </p:cNvPr>
@@ -2614,7 +2614,7 @@
           <a:bodyPr/>
           <a:lstStyle/>
           <a:p>
-            <a:fld id="{483134EA-AF8E-4025-9293-54B9F96F6B5B}" type="slidenum">
+            <a:fld id="{908A8051-4A3C-4A59-A03A-228B1FECC8A9}" type="slidenum">
               <a:rPr lang="en-150" smtClean="0"/>
               <a:t>‹#›</a:t>
             </a:fld>
@@ -2625,7 +2625,7 @@
     </p:spTree>
     <p:extLst>
       <p:ext uri="{BB962C8B-B14F-4D97-AF65-F5344CB8AC3E}">
-        <p14:creationId xmlns:p14="http://schemas.microsoft.com/office/powerpoint/2010/main" val="3927260678"/>
+        <p14:creationId xmlns:p14="http://schemas.microsoft.com/office/powerpoint/2010/main" val="1902303581"/>
       </p:ext>
     </p:extLst>
   </p:cSld>
@@ -2657,7 +2657,7 @@
           <p:cNvPr id="2" name="Title 1">
             <a:extLst>
               <a:ext uri="{FF2B5EF4-FFF2-40B4-BE49-F238E27FC236}">
-                <a16:creationId xmlns:a16="http://schemas.microsoft.com/office/drawing/2014/main" id="{7C67C092-70C4-55E7-9C0C-49CDC4466479}"/>
+                <a16:creationId xmlns:a16="http://schemas.microsoft.com/office/drawing/2014/main" id="{C4B193E2-62BA-B02F-7DEC-0AD0DF3876C2}"/>
               </a:ext>
             </a:extLst>
           </p:cNvPr>
@@ -2686,7 +2686,7 @@
           <p:cNvPr id="3" name="Content Placeholder 2">
             <a:extLst>
               <a:ext uri="{FF2B5EF4-FFF2-40B4-BE49-F238E27FC236}">
-                <a16:creationId xmlns:a16="http://schemas.microsoft.com/office/drawing/2014/main" id="{B6BB800B-961D-2BD0-4041-CA3A599B4BD4}"/>
+                <a16:creationId xmlns:a16="http://schemas.microsoft.com/office/drawing/2014/main" id="{B480DC23-F8F3-40E3-E32E-0A25D09CDEA0}"/>
               </a:ext>
             </a:extLst>
           </p:cNvPr>
@@ -2749,7 +2749,7 @@
           <p:cNvPr id="4" name="Content Placeholder 3">
             <a:extLst>
               <a:ext uri="{FF2B5EF4-FFF2-40B4-BE49-F238E27FC236}">
-                <a16:creationId xmlns:a16="http://schemas.microsoft.com/office/drawing/2014/main" id="{4E628F9F-9463-3C20-7D0D-A5318AB67937}"/>
+                <a16:creationId xmlns:a16="http://schemas.microsoft.com/office/drawing/2014/main" id="{6AFE01C3-43B3-748A-04E4-D6CE21B53A31}"/>
               </a:ext>
             </a:extLst>
           </p:cNvPr>
@@ -2812,7 +2812,7 @@
           <p:cNvPr id="5" name="Date Placeholder 4">
             <a:extLst>
               <a:ext uri="{FF2B5EF4-FFF2-40B4-BE49-F238E27FC236}">
-                <a16:creationId xmlns:a16="http://schemas.microsoft.com/office/drawing/2014/main" id="{97CB8A01-539C-F9AA-745D-EF521017CC07}"/>
+                <a16:creationId xmlns:a16="http://schemas.microsoft.com/office/drawing/2014/main" id="{BCAD2EF5-F93F-A677-DC29-572D6587816B}"/>
               </a:ext>
             </a:extLst>
           </p:cNvPr>
@@ -2828,7 +2828,7 @@
           <a:bodyPr/>
           <a:lstStyle/>
           <a:p>
-            <a:fld id="{28A79F54-38CD-430F-B2A3-583392FA0233}" type="datetimeFigureOut">
+            <a:fld id="{7E5F07D2-0123-4E0E-8F81-2812B80D41D9}" type="datetimeFigureOut">
               <a:rPr lang="en-150" smtClean="0"/>
               <a:t>26/10/2026</a:t>
             </a:fld>
@@ -2841,7 +2841,7 @@
           <p:cNvPr id="6" name="Footer Placeholder 5">
             <a:extLst>
               <a:ext uri="{FF2B5EF4-FFF2-40B4-BE49-F238E27FC236}">
-                <a16:creationId xmlns:a16="http://schemas.microsoft.com/office/drawing/2014/main" id="{A2148F65-5B8A-1CCD-365F-EDDF830FA0E1}"/>
+                <a16:creationId xmlns:a16="http://schemas.microsoft.com/office/drawing/2014/main" id="{339D1FB9-BBF0-85F3-837B-F895B2A8EFC7}"/>
               </a:ext>
             </a:extLst>
           </p:cNvPr>
@@ -2866,7 +2866,7 @@
           <p:cNvPr id="7" name="Slide Number Placeholder 6">
             <a:extLst>
               <a:ext uri="{FF2B5EF4-FFF2-40B4-BE49-F238E27FC236}">
-                <a16:creationId xmlns:a16="http://schemas.microsoft.com/office/drawing/2014/main" id="{618935FF-934A-30B7-3D15-A05208D85DE5}"/>
+                <a16:creationId xmlns:a16="http://schemas.microsoft.com/office/drawing/2014/main" id="{4118C572-ECFA-F156-8790-06769693FA13}"/>
               </a:ext>
             </a:extLst>
           </p:cNvPr>
@@ -2882,7 +2882,7 @@
           <a:bodyPr/>
           <a:lstStyle/>
           <a:p>
-            <a:fld id="{483134EA-AF8E-4025-9293-54B9F96F6B5B}" type="slidenum">
+            <a:fld id="{908A8051-4A3C-4A59-A03A-228B1FECC8A9}" type="slidenum">
               <a:rPr lang="en-150" smtClean="0"/>
               <a:t>‹#›</a:t>
             </a:fld>
@@ -2893,7 +2893,7 @@
     </p:spTree>
     <p:extLst>
       <p:ext uri="{BB962C8B-B14F-4D97-AF65-F5344CB8AC3E}">
-        <p14:creationId xmlns:p14="http://schemas.microsoft.com/office/powerpoint/2010/main" val="4122032615"/>
+        <p14:creationId xmlns:p14="http://schemas.microsoft.com/office/powerpoint/2010/main" val="31414312"/>
       </p:ext>
     </p:extLst>
   </p:cSld>
@@ -2925,7 +2925,7 @@
           <p:cNvPr id="2" name="Title 1">
             <a:extLst>
               <a:ext uri="{FF2B5EF4-FFF2-40B4-BE49-F238E27FC236}">
-                <a16:creationId xmlns:a16="http://schemas.microsoft.com/office/drawing/2014/main" id="{63045C49-99BC-A3B5-5C59-C2F6AB54C1F3}"/>
+                <a16:creationId xmlns:a16="http://schemas.microsoft.com/office/drawing/2014/main" id="{FD826561-690C-0DA3-F878-F4C83D644796}"/>
               </a:ext>
             </a:extLst>
           </p:cNvPr>
@@ -2959,7 +2959,7 @@
           <p:cNvPr id="3" name="Text Placeholder 2">
             <a:extLst>
               <a:ext uri="{FF2B5EF4-FFF2-40B4-BE49-F238E27FC236}">
-                <a16:creationId xmlns:a16="http://schemas.microsoft.com/office/drawing/2014/main" id="{B95B9D02-4762-C2F4-C532-E4B3E0430C84}"/>
+                <a16:creationId xmlns:a16="http://schemas.microsoft.com/office/drawing/2014/main" id="{4F1BB2E7-D315-66CF-2095-703F1934E8B4}"/>
               </a:ext>
             </a:extLst>
           </p:cNvPr>
@@ -3030,7 +3030,7 @@
           <p:cNvPr id="4" name="Content Placeholder 3">
             <a:extLst>
               <a:ext uri="{FF2B5EF4-FFF2-40B4-BE49-F238E27FC236}">
-                <a16:creationId xmlns:a16="http://schemas.microsoft.com/office/drawing/2014/main" id="{B004486A-78B8-8E72-6683-39BEF0DC76D0}"/>
+                <a16:creationId xmlns:a16="http://schemas.microsoft.com/office/drawing/2014/main" id="{96E21A05-9BB2-D60B-DD97-B27307983DCA}"/>
               </a:ext>
             </a:extLst>
           </p:cNvPr>
@@ -3093,7 +3093,7 @@
           <p:cNvPr id="5" name="Text Placeholder 4">
             <a:extLst>
               <a:ext uri="{FF2B5EF4-FFF2-40B4-BE49-F238E27FC236}">
-                <a16:creationId xmlns:a16="http://schemas.microsoft.com/office/drawing/2014/main" id="{C589AAC7-4CC3-8CDD-F042-DB512853A005}"/>
+                <a16:creationId xmlns:a16="http://schemas.microsoft.com/office/drawing/2014/main" id="{5BE03B84-0986-A318-C86D-1E1717077B80}"/>
               </a:ext>
             </a:extLst>
           </p:cNvPr>
@@ -3164,7 +3164,7 @@
           <p:cNvPr id="6" name="Content Placeholder 5">
             <a:extLst>
               <a:ext uri="{FF2B5EF4-FFF2-40B4-BE49-F238E27FC236}">
-                <a16:creationId xmlns:a16="http://schemas.microsoft.com/office/drawing/2014/main" id="{F393450F-4B1D-30CF-686B-3DA9297421F3}"/>
+                <a16:creationId xmlns:a16="http://schemas.microsoft.com/office/drawing/2014/main" id="{AEF20FC1-8C14-78DA-CA50-8D53913872F6}"/>
               </a:ext>
             </a:extLst>
           </p:cNvPr>
@@ -3227,7 +3227,7 @@
           <p:cNvPr id="7" name="Date Placeholder 6">
             <a:extLst>
               <a:ext uri="{FF2B5EF4-FFF2-40B4-BE49-F238E27FC236}">
-                <a16:creationId xmlns:a16="http://schemas.microsoft.com/office/drawing/2014/main" id="{53ECA32B-2A50-E83D-3B52-4CCBE8247F1D}"/>
+                <a16:creationId xmlns:a16="http://schemas.microsoft.com/office/drawing/2014/main" id="{64AEF4E0-2188-E762-28FA-E20BF68A4901}"/>
               </a:ext>
             </a:extLst>
           </p:cNvPr>
@@ -3243,7 +3243,7 @@
           <a:bodyPr/>
           <a:lstStyle/>
           <a:p>
-            <a:fld id="{28A79F54-38CD-430F-B2A3-583392FA0233}" type="datetimeFigureOut">
+            <a:fld id="{7E5F07D2-0123-4E0E-8F81-2812B80D41D9}" type="datetimeFigureOut">
               <a:rPr lang="en-150" smtClean="0"/>
               <a:t>26/10/2026</a:t>
             </a:fld>
@@ -3256,7 +3256,7 @@
           <p:cNvPr id="8" name="Footer Placeholder 7">
             <a:extLst>
               <a:ext uri="{FF2B5EF4-FFF2-40B4-BE49-F238E27FC236}">
-                <a16:creationId xmlns:a16="http://schemas.microsoft.com/office/drawing/2014/main" id="{E857B428-26AE-D61A-299E-DDA2E71DFCF2}"/>
+                <a16:creationId xmlns:a16="http://schemas.microsoft.com/office/drawing/2014/main" id="{3336C1D1-1AA6-2F31-9612-91659FD2FE18}"/>
               </a:ext>
             </a:extLst>
           </p:cNvPr>
@@ -3281,7 +3281,7 @@
           <p:cNvPr id="9" name="Slide Number Placeholder 8">
             <a:extLst>
               <a:ext uri="{FF2B5EF4-FFF2-40B4-BE49-F238E27FC236}">
-                <a16:creationId xmlns:a16="http://schemas.microsoft.com/office/drawing/2014/main" id="{14833C2E-E6B6-90F1-E002-1D36A37071F6}"/>
+                <a16:creationId xmlns:a16="http://schemas.microsoft.com/office/drawing/2014/main" id="{FE4FE425-4138-1C03-1031-5BF260ED8BF6}"/>
               </a:ext>
             </a:extLst>
           </p:cNvPr>
@@ -3297,7 +3297,7 @@
           <a:bodyPr/>
           <a:lstStyle/>
           <a:p>
-            <a:fld id="{483134EA-AF8E-4025-9293-54B9F96F6B5B}" type="slidenum">
+            <a:fld id="{908A8051-4A3C-4A59-A03A-228B1FECC8A9}" type="slidenum">
               <a:rPr lang="en-150" smtClean="0"/>
               <a:t>‹#›</a:t>
             </a:fld>
@@ -3308,7 +3308,7 @@
     </p:spTree>
     <p:extLst>
       <p:ext uri="{BB962C8B-B14F-4D97-AF65-F5344CB8AC3E}">
-        <p14:creationId xmlns:p14="http://schemas.microsoft.com/office/powerpoint/2010/main" val="1536324592"/>
+        <p14:creationId xmlns:p14="http://schemas.microsoft.com/office/powerpoint/2010/main" val="3983320988"/>
       </p:ext>
     </p:extLst>
   </p:cSld>
@@ -3340,7 +3340,7 @@
           <p:cNvPr id="2" name="Title 1">
             <a:extLst>
               <a:ext uri="{FF2B5EF4-FFF2-40B4-BE49-F238E27FC236}">
-                <a16:creationId xmlns:a16="http://schemas.microsoft.com/office/drawing/2014/main" id="{FC0C6334-4CFC-9D15-C4E9-76B93DD0383C}"/>
+                <a16:creationId xmlns:a16="http://schemas.microsoft.com/office/drawing/2014/main" id="{5EE185DF-FB13-914D-8BE6-8DE36F39E45F}"/>
               </a:ext>
             </a:extLst>
           </p:cNvPr>
@@ -3369,7 +3369,7 @@
           <p:cNvPr id="3" name="Date Placeholder 2">
             <a:extLst>
               <a:ext uri="{FF2B5EF4-FFF2-40B4-BE49-F238E27FC236}">
-                <a16:creationId xmlns:a16="http://schemas.microsoft.com/office/drawing/2014/main" id="{4855298E-339E-FEC4-E435-14F019FA9962}"/>
+                <a16:creationId xmlns:a16="http://schemas.microsoft.com/office/drawing/2014/main" id="{724D0085-D4D6-C572-661C-67511924595E}"/>
               </a:ext>
             </a:extLst>
           </p:cNvPr>
@@ -3385,7 +3385,7 @@
           <a:bodyPr/>
           <a:lstStyle/>
           <a:p>
-            <a:fld id="{28A79F54-38CD-430F-B2A3-583392FA0233}" type="datetimeFigureOut">
+            <a:fld id="{7E5F07D2-0123-4E0E-8F81-2812B80D41D9}" type="datetimeFigureOut">
               <a:rPr lang="en-150" smtClean="0"/>
               <a:t>26/10/2026</a:t>
             </a:fld>
@@ -3398,7 +3398,7 @@
           <p:cNvPr id="4" name="Footer Placeholder 3">
             <a:extLst>
               <a:ext uri="{FF2B5EF4-FFF2-40B4-BE49-F238E27FC236}">
-                <a16:creationId xmlns:a16="http://schemas.microsoft.com/office/drawing/2014/main" id="{93466E65-6EF6-B794-2D7A-1728937BE8E5}"/>
+                <a16:creationId xmlns:a16="http://schemas.microsoft.com/office/drawing/2014/main" id="{26164D6F-64A0-C4E1-3F39-1B0DB28121D3}"/>
               </a:ext>
             </a:extLst>
           </p:cNvPr>
@@ -3423,7 +3423,7 @@
           <p:cNvPr id="5" name="Slide Number Placeholder 4">
             <a:extLst>
               <a:ext uri="{FF2B5EF4-FFF2-40B4-BE49-F238E27FC236}">
-                <a16:creationId xmlns:a16="http://schemas.microsoft.com/office/drawing/2014/main" id="{5174F70B-4AE0-65E4-C83D-2F77319EF17D}"/>
+                <a16:creationId xmlns:a16="http://schemas.microsoft.com/office/drawing/2014/main" id="{F1FA05E4-3823-BDD7-16A7-5A2D75BE3F72}"/>
               </a:ext>
             </a:extLst>
           </p:cNvPr>
@@ -3439,7 +3439,7 @@
           <a:bodyPr/>
           <a:lstStyle/>
           <a:p>
-            <a:fld id="{483134EA-AF8E-4025-9293-54B9F96F6B5B}" type="slidenum">
+            <a:fld id="{908A8051-4A3C-4A59-A03A-228B1FECC8A9}" type="slidenum">
               <a:rPr lang="en-150" smtClean="0"/>
               <a:t>‹#›</a:t>
             </a:fld>
@@ -3450,7 +3450,7 @@
     </p:spTree>
     <p:extLst>
       <p:ext uri="{BB962C8B-B14F-4D97-AF65-F5344CB8AC3E}">
-        <p14:creationId xmlns:p14="http://schemas.microsoft.com/office/powerpoint/2010/main" val="952314981"/>
+        <p14:creationId xmlns:p14="http://schemas.microsoft.com/office/powerpoint/2010/main" val="2330890001"/>
       </p:ext>
     </p:extLst>
   </p:cSld>
@@ -3482,7 +3482,7 @@
           <p:cNvPr id="2" name="Date Placeholder 1">
             <a:extLst>
               <a:ext uri="{FF2B5EF4-FFF2-40B4-BE49-F238E27FC236}">
-                <a16:creationId xmlns:a16="http://schemas.microsoft.com/office/drawing/2014/main" id="{3689944D-130F-405E-9B9B-1E6EC88E5F1B}"/>
+                <a16:creationId xmlns:a16="http://schemas.microsoft.com/office/drawing/2014/main" id="{4FFDF003-223C-0952-F74D-51E198808E9A}"/>
               </a:ext>
             </a:extLst>
           </p:cNvPr>
@@ -3498,7 +3498,7 @@
           <a:bodyPr/>
           <a:lstStyle/>
           <a:p>
-            <a:fld id="{28A79F54-38CD-430F-B2A3-583392FA0233}" type="datetimeFigureOut">
+            <a:fld id="{7E5F07D2-0123-4E0E-8F81-2812B80D41D9}" type="datetimeFigureOut">
               <a:rPr lang="en-150" smtClean="0"/>
               <a:t>26/10/2026</a:t>
             </a:fld>
@@ -3511,7 +3511,7 @@
           <p:cNvPr id="3" name="Footer Placeholder 2">
             <a:extLst>
               <a:ext uri="{FF2B5EF4-FFF2-40B4-BE49-F238E27FC236}">
-                <a16:creationId xmlns:a16="http://schemas.microsoft.com/office/drawing/2014/main" id="{5224B959-79A4-AA90-110F-8BE2A9DBD681}"/>
+                <a16:creationId xmlns:a16="http://schemas.microsoft.com/office/drawing/2014/main" id="{D100C4BB-F812-CA87-FAE7-71265430C499}"/>
               </a:ext>
             </a:extLst>
           </p:cNvPr>
@@ -3536,7 +3536,7 @@
           <p:cNvPr id="4" name="Slide Number Placeholder 3">
             <a:extLst>
               <a:ext uri="{FF2B5EF4-FFF2-40B4-BE49-F238E27FC236}">
-                <a16:creationId xmlns:a16="http://schemas.microsoft.com/office/drawing/2014/main" id="{7D5735B8-71C1-C480-085A-80A235D5E83B}"/>
+                <a16:creationId xmlns:a16="http://schemas.microsoft.com/office/drawing/2014/main" id="{415989B4-7527-0986-360A-ED9B039D14D3}"/>
               </a:ext>
             </a:extLst>
           </p:cNvPr>
@@ -3552,7 +3552,7 @@
           <a:bodyPr/>
           <a:lstStyle/>
           <a:p>
-            <a:fld id="{483134EA-AF8E-4025-9293-54B9F96F6B5B}" type="slidenum">
+            <a:fld id="{908A8051-4A3C-4A59-A03A-228B1FECC8A9}" type="slidenum">
               <a:rPr lang="en-150" smtClean="0"/>
               <a:t>‹#›</a:t>
             </a:fld>
@@ -3563,7 +3563,7 @@
     </p:spTree>
     <p:extLst>
       <p:ext uri="{BB962C8B-B14F-4D97-AF65-F5344CB8AC3E}">
-        <p14:creationId xmlns:p14="http://schemas.microsoft.com/office/powerpoint/2010/main" val="4036830473"/>
+        <p14:creationId xmlns:p14="http://schemas.microsoft.com/office/powerpoint/2010/main" val="972084789"/>
       </p:ext>
     </p:extLst>
   </p:cSld>
@@ -3595,7 +3595,7 @@
           <p:cNvPr id="2" name="Title 1">
             <a:extLst>
               <a:ext uri="{FF2B5EF4-FFF2-40B4-BE49-F238E27FC236}">
-                <a16:creationId xmlns:a16="http://schemas.microsoft.com/office/drawing/2014/main" id="{9058F230-BA79-015E-D108-7B45496A0FF3}"/>
+                <a16:creationId xmlns:a16="http://schemas.microsoft.com/office/drawing/2014/main" id="{FA5603E0-8635-6C33-6379-8AFCA790F7E7}"/>
               </a:ext>
             </a:extLst>
           </p:cNvPr>
@@ -3633,7 +3633,7 @@
           <p:cNvPr id="3" name="Content Placeholder 2">
             <a:extLst>
               <a:ext uri="{FF2B5EF4-FFF2-40B4-BE49-F238E27FC236}">
-                <a16:creationId xmlns:a16="http://schemas.microsoft.com/office/drawing/2014/main" id="{352FDCDC-1E1B-5294-46AE-EF7FE809652F}"/>
+                <a16:creationId xmlns:a16="http://schemas.microsoft.com/office/drawing/2014/main" id="{8951B56E-745F-3862-360B-4437F32E99DE}"/>
               </a:ext>
             </a:extLst>
           </p:cNvPr>
@@ -3724,7 +3724,7 @@
           <p:cNvPr id="4" name="Text Placeholder 3">
             <a:extLst>
               <a:ext uri="{FF2B5EF4-FFF2-40B4-BE49-F238E27FC236}">
-                <a16:creationId xmlns:a16="http://schemas.microsoft.com/office/drawing/2014/main" id="{B0086479-E0E1-CC88-7E82-379F29DFB5AC}"/>
+                <a16:creationId xmlns:a16="http://schemas.microsoft.com/office/drawing/2014/main" id="{DC390514-FC50-50F6-ED1A-E2E148B694B2}"/>
               </a:ext>
             </a:extLst>
           </p:cNvPr>
@@ -3795,7 +3795,7 @@
           <p:cNvPr id="5" name="Date Placeholder 4">
             <a:extLst>
               <a:ext uri="{FF2B5EF4-FFF2-40B4-BE49-F238E27FC236}">
-                <a16:creationId xmlns:a16="http://schemas.microsoft.com/office/drawing/2014/main" id="{BB192735-25D5-5D04-C0AF-51D6DE3DA41A}"/>
+                <a16:creationId xmlns:a16="http://schemas.microsoft.com/office/drawing/2014/main" id="{82700A86-B2B8-9AC2-412A-25095D87809F}"/>
               </a:ext>
             </a:extLst>
           </p:cNvPr>
@@ -3811,7 +3811,7 @@
           <a:bodyPr/>
           <a:lstStyle/>
           <a:p>
-            <a:fld id="{28A79F54-38CD-430F-B2A3-583392FA0233}" type="datetimeFigureOut">
+            <a:fld id="{7E5F07D2-0123-4E0E-8F81-2812B80D41D9}" type="datetimeFigureOut">
               <a:rPr lang="en-150" smtClean="0"/>
               <a:t>26/10/2026</a:t>
             </a:fld>
@@ -3824,7 +3824,7 @@
           <p:cNvPr id="6" name="Footer Placeholder 5">
             <a:extLst>
               <a:ext uri="{FF2B5EF4-FFF2-40B4-BE49-F238E27FC236}">
-                <a16:creationId xmlns:a16="http://schemas.microsoft.com/office/drawing/2014/main" id="{6C6F51D0-AE81-F36C-6718-FBF5A25B1850}"/>
+                <a16:creationId xmlns:a16="http://schemas.microsoft.com/office/drawing/2014/main" id="{55FA5E03-20DA-DEED-A3DD-280EE06C90DA}"/>
               </a:ext>
             </a:extLst>
           </p:cNvPr>
@@ -3849,7 +3849,7 @@
           <p:cNvPr id="7" name="Slide Number Placeholder 6">
             <a:extLst>
               <a:ext uri="{FF2B5EF4-FFF2-40B4-BE49-F238E27FC236}">
-                <a16:creationId xmlns:a16="http://schemas.microsoft.com/office/drawing/2014/main" id="{13EBEFA3-6D91-3F7A-AFCC-39F3447B34B0}"/>
+                <a16:creationId xmlns:a16="http://schemas.microsoft.com/office/drawing/2014/main" id="{00F8A101-3DAC-5D68-674A-825AD9689923}"/>
               </a:ext>
             </a:extLst>
           </p:cNvPr>
@@ -3865,7 +3865,7 @@
           <a:bodyPr/>
           <a:lstStyle/>
           <a:p>
-            <a:fld id="{483134EA-AF8E-4025-9293-54B9F96F6B5B}" type="slidenum">
+            <a:fld id="{908A8051-4A3C-4A59-A03A-228B1FECC8A9}" type="slidenum">
               <a:rPr lang="en-150" smtClean="0"/>
               <a:t>‹#›</a:t>
             </a:fld>
@@ -3876,7 +3876,7 @@
     </p:spTree>
     <p:extLst>
       <p:ext uri="{BB962C8B-B14F-4D97-AF65-F5344CB8AC3E}">
-        <p14:creationId xmlns:p14="http://schemas.microsoft.com/office/powerpoint/2010/main" val="1113620046"/>
+        <p14:creationId xmlns:p14="http://schemas.microsoft.com/office/powerpoint/2010/main" val="1148663239"/>
       </p:ext>
     </p:extLst>
   </p:cSld>
@@ -3908,7 +3908,7 @@
           <p:cNvPr id="2" name="Title 1">
             <a:extLst>
               <a:ext uri="{FF2B5EF4-FFF2-40B4-BE49-F238E27FC236}">
-                <a16:creationId xmlns:a16="http://schemas.microsoft.com/office/drawing/2014/main" id="{824E74B7-D251-495B-E411-F07C7807D66D}"/>
+                <a16:creationId xmlns:a16="http://schemas.microsoft.com/office/drawing/2014/main" id="{DFBDCF3F-1038-F948-8DEA-E7E5BEE78889}"/>
               </a:ext>
             </a:extLst>
           </p:cNvPr>
@@ -3946,7 +3946,7 @@
           <p:cNvPr id="3" name="Picture Placeholder 2">
             <a:extLst>
               <a:ext uri="{FF2B5EF4-FFF2-40B4-BE49-F238E27FC236}">
-                <a16:creationId xmlns:a16="http://schemas.microsoft.com/office/drawing/2014/main" id="{F1B88DE9-B81A-9408-CA68-65588F6CC0CB}"/>
+                <a16:creationId xmlns:a16="http://schemas.microsoft.com/office/drawing/2014/main" id="{192838F8-90AD-CD1C-22D9-D8291F5606A8}"/>
               </a:ext>
             </a:extLst>
           </p:cNvPr>
@@ -4013,7 +4013,7 @@
           <p:cNvPr id="4" name="Text Placeholder 3">
             <a:extLst>
               <a:ext uri="{FF2B5EF4-FFF2-40B4-BE49-F238E27FC236}">
-                <a16:creationId xmlns:a16="http://schemas.microsoft.com/office/drawing/2014/main" id="{CE70266E-F853-CAC7-093D-45423AFF336E}"/>
+                <a16:creationId xmlns:a16="http://schemas.microsoft.com/office/drawing/2014/main" id="{7B2B8403-2B75-8519-521A-655EAC0DFA33}"/>
               </a:ext>
             </a:extLst>
           </p:cNvPr>
@@ -4084,7 +4084,7 @@
           <p:cNvPr id="5" name="Date Placeholder 4">
             <a:extLst>
               <a:ext uri="{FF2B5EF4-FFF2-40B4-BE49-F238E27FC236}">
-                <a16:creationId xmlns:a16="http://schemas.microsoft.com/office/drawing/2014/main" id="{D5FBAB7F-1CAB-F30B-84AC-AD67446A65C7}"/>
+                <a16:creationId xmlns:a16="http://schemas.microsoft.com/office/drawing/2014/main" id="{AEAB6114-EFAD-3A5D-751A-7EDD5F435E4A}"/>
               </a:ext>
             </a:extLst>
           </p:cNvPr>
@@ -4100,7 +4100,7 @@
           <a:bodyPr/>
           <a:lstStyle/>
           <a:p>
-            <a:fld id="{28A79F54-38CD-430F-B2A3-583392FA0233}" type="datetimeFigureOut">
+            <a:fld id="{7E5F07D2-0123-4E0E-8F81-2812B80D41D9}" type="datetimeFigureOut">
               <a:rPr lang="en-150" smtClean="0"/>
               <a:t>26/10/2026</a:t>
             </a:fld>
@@ -4113,7 +4113,7 @@
           <p:cNvPr id="6" name="Footer Placeholder 5">
             <a:extLst>
               <a:ext uri="{FF2B5EF4-FFF2-40B4-BE49-F238E27FC236}">
-                <a16:creationId xmlns:a16="http://schemas.microsoft.com/office/drawing/2014/main" id="{B7A2CB9A-CC7A-5594-B15A-D0BACF357A47}"/>
+                <a16:creationId xmlns:a16="http://schemas.microsoft.com/office/drawing/2014/main" id="{DB1FD87C-D50F-396B-51D3-B3B82FBFDF33}"/>
               </a:ext>
             </a:extLst>
           </p:cNvPr>
@@ -4138,7 +4138,7 @@
           <p:cNvPr id="7" name="Slide Number Placeholder 6">
             <a:extLst>
               <a:ext uri="{FF2B5EF4-FFF2-40B4-BE49-F238E27FC236}">
-                <a16:creationId xmlns:a16="http://schemas.microsoft.com/office/drawing/2014/main" id="{6A842DB7-F98F-EACB-5029-E3147C1203C3}"/>
+                <a16:creationId xmlns:a16="http://schemas.microsoft.com/office/drawing/2014/main" id="{27220D6A-73A1-3BCC-0ECF-955DE159183B}"/>
               </a:ext>
             </a:extLst>
           </p:cNvPr>
@@ -4154,7 +4154,7 @@
           <a:bodyPr/>
           <a:lstStyle/>
           <a:p>
-            <a:fld id="{483134EA-AF8E-4025-9293-54B9F96F6B5B}" type="slidenum">
+            <a:fld id="{908A8051-4A3C-4A59-A03A-228B1FECC8A9}" type="slidenum">
               <a:rPr lang="en-150" smtClean="0"/>
               <a:t>‹#›</a:t>
             </a:fld>
@@ -4165,7 +4165,7 @@
     </p:spTree>
     <p:extLst>
       <p:ext uri="{BB962C8B-B14F-4D97-AF65-F5344CB8AC3E}">
-        <p14:creationId xmlns:p14="http://schemas.microsoft.com/office/powerpoint/2010/main" val="919283452"/>
+        <p14:creationId xmlns:p14="http://schemas.microsoft.com/office/powerpoint/2010/main" val="375605174"/>
       </p:ext>
     </p:extLst>
   </p:cSld>
@@ -4202,7 +4202,7 @@
           <p:cNvPr id="2" name="Title Placeholder 1">
             <a:extLst>
               <a:ext uri="{FF2B5EF4-FFF2-40B4-BE49-F238E27FC236}">
-                <a16:creationId xmlns:a16="http://schemas.microsoft.com/office/drawing/2014/main" id="{D3C89E0E-627E-E546-ADCD-D1D033A28461}"/>
+                <a16:creationId xmlns:a16="http://schemas.microsoft.com/office/drawing/2014/main" id="{69EB9727-A9FE-6009-266C-CB131791E0BD}"/>
               </a:ext>
             </a:extLst>
           </p:cNvPr>
@@ -4241,7 +4241,7 @@
           <p:cNvPr id="3" name="Text Placeholder 2">
             <a:extLst>
               <a:ext uri="{FF2B5EF4-FFF2-40B4-BE49-F238E27FC236}">
-                <a16:creationId xmlns:a16="http://schemas.microsoft.com/office/drawing/2014/main" id="{5B1839DB-AFF2-E2DD-AE55-FC8114A975C1}"/>
+                <a16:creationId xmlns:a16="http://schemas.microsoft.com/office/drawing/2014/main" id="{32556276-E816-9484-582A-89F6F42FAB54}"/>
               </a:ext>
             </a:extLst>
           </p:cNvPr>
@@ -4309,7 +4309,7 @@
           <p:cNvPr id="4" name="Date Placeholder 3">
             <a:extLst>
               <a:ext uri="{FF2B5EF4-FFF2-40B4-BE49-F238E27FC236}">
-                <a16:creationId xmlns:a16="http://schemas.microsoft.com/office/drawing/2014/main" id="{09385A5C-ABE7-C6C9-9087-F522B4A9F54E}"/>
+                <a16:creationId xmlns:a16="http://schemas.microsoft.com/office/drawing/2014/main" id="{C4595226-47B6-0DEF-3B58-D269631F13F9}"/>
               </a:ext>
             </a:extLst>
           </p:cNvPr>
@@ -4343,7 +4343,7 @@
             </a:lvl1pPr>
           </a:lstStyle>
           <a:p>
-            <a:fld id="{28A79F54-38CD-430F-B2A3-583392FA0233}" type="datetimeFigureOut">
+            <a:fld id="{7E5F07D2-0123-4E0E-8F81-2812B80D41D9}" type="datetimeFigureOut">
               <a:rPr lang="en-150" smtClean="0"/>
               <a:t>26/10/2026</a:t>
             </a:fld>
@@ -4356,7 +4356,7 @@
           <p:cNvPr id="5" name="Footer Placeholder 4">
             <a:extLst>
               <a:ext uri="{FF2B5EF4-FFF2-40B4-BE49-F238E27FC236}">
-                <a16:creationId xmlns:a16="http://schemas.microsoft.com/office/drawing/2014/main" id="{C72874CB-843C-2D16-8EA9-D0990228F593}"/>
+                <a16:creationId xmlns:a16="http://schemas.microsoft.com/office/drawing/2014/main" id="{77678738-37A0-3C64-E9FE-5759DAFE8226}"/>
               </a:ext>
             </a:extLst>
           </p:cNvPr>
@@ -4399,7 +4399,7 @@
           <p:cNvPr id="6" name="Slide Number Placeholder 5">
             <a:extLst>
               <a:ext uri="{FF2B5EF4-FFF2-40B4-BE49-F238E27FC236}">
-                <a16:creationId xmlns:a16="http://schemas.microsoft.com/office/drawing/2014/main" id="{F525350D-3880-2657-1BBE-C8F56B74DE2B}"/>
+                <a16:creationId xmlns:a16="http://schemas.microsoft.com/office/drawing/2014/main" id="{E2BCC8AA-F378-1D98-8827-43C23BEF8A60}"/>
               </a:ext>
             </a:extLst>
           </p:cNvPr>
@@ -4433,7 +4433,7 @@
             </a:lvl1pPr>
           </a:lstStyle>
           <a:p>
-            <a:fld id="{483134EA-AF8E-4025-9293-54B9F96F6B5B}" type="slidenum">
+            <a:fld id="{908A8051-4A3C-4A59-A03A-228B1FECC8A9}" type="slidenum">
               <a:rPr lang="en-150" smtClean="0"/>
               <a:t>‹#›</a:t>
             </a:fld>
@@ -4444,7 +4444,7 @@
     </p:spTree>
     <p:extLst>
       <p:ext uri="{BB962C8B-B14F-4D97-AF65-F5344CB8AC3E}">
-        <p14:creationId xmlns:p14="http://schemas.microsoft.com/office/powerpoint/2010/main" val="310042960"/>
+        <p14:creationId xmlns:p14="http://schemas.microsoft.com/office/powerpoint/2010/main" val="296557655"/>
       </p:ext>
     </p:extLst>
   </p:cSld>
@@ -4775,7 +4775,7 @@
           <p:cNvPr id="2" name="Rectangle 1">
             <a:extLst>
               <a:ext uri="{FF2B5EF4-FFF2-40B4-BE49-F238E27FC236}">
-                <a16:creationId xmlns:a16="http://schemas.microsoft.com/office/drawing/2014/main" id="{EDE4F967-16FF-7127-7CB8-4CA27FE6A80B}"/>
+                <a16:creationId xmlns:a16="http://schemas.microsoft.com/office/drawing/2014/main" id="{9A60AFD8-79BA-8D3D-0784-3180561E2957}"/>
               </a:ext>
             </a:extLst>
           </p:cNvPr>
@@ -4843,7 +4843,7 @@
           <p:cNvPr id="3" name="TextBox 2">
             <a:extLst>
               <a:ext uri="{FF2B5EF4-FFF2-40B4-BE49-F238E27FC236}">
-                <a16:creationId xmlns:a16="http://schemas.microsoft.com/office/drawing/2014/main" id="{05AB0A28-BB99-886E-12F1-CB5A47A68134}"/>
+                <a16:creationId xmlns:a16="http://schemas.microsoft.com/office/drawing/2014/main" id="{385D5157-D977-2556-7B8F-F3C6E3ECF2FE}"/>
               </a:ext>
             </a:extLst>
           </p:cNvPr>
@@ -4894,7 +4894,7 @@
           <p:cNvPr id="4" name="TextBox 3">
             <a:extLst>
               <a:ext uri="{FF2B5EF4-FFF2-40B4-BE49-F238E27FC236}">
-                <a16:creationId xmlns:a16="http://schemas.microsoft.com/office/drawing/2014/main" id="{768E7187-C539-DC41-7F38-2AF2F09D242C}"/>
+                <a16:creationId xmlns:a16="http://schemas.microsoft.com/office/drawing/2014/main" id="{C46B190C-9DA7-2BA9-55B7-B48853F92773}"/>
               </a:ext>
             </a:extLst>
           </p:cNvPr>
@@ -4945,7 +4945,7 @@
           <p:cNvPr id="5" name="TextBox 4">
             <a:extLst>
               <a:ext uri="{FF2B5EF4-FFF2-40B4-BE49-F238E27FC236}">
-                <a16:creationId xmlns:a16="http://schemas.microsoft.com/office/drawing/2014/main" id="{AECF1C6D-B8D8-12AF-8E64-447F444B8C16}"/>
+                <a16:creationId xmlns:a16="http://schemas.microsoft.com/office/drawing/2014/main" id="{CE5FE5C9-9C7B-E2F5-BD72-F8E9743F14D4}"/>
               </a:ext>
             </a:extLst>
           </p:cNvPr>
@@ -5028,7 +5028,7 @@
           <p:cNvPr id="6" name="TextBox 5">
             <a:extLst>
               <a:ext uri="{FF2B5EF4-FFF2-40B4-BE49-F238E27FC236}">
-                <a16:creationId xmlns:a16="http://schemas.microsoft.com/office/drawing/2014/main" id="{ABDB06D3-54BB-B112-FD9E-C7DD55CBA458}"/>
+                <a16:creationId xmlns:a16="http://schemas.microsoft.com/office/drawing/2014/main" id="{23F4D9EA-902A-1882-E738-6662A9439026}"/>
               </a:ext>
             </a:extLst>
           </p:cNvPr>
@@ -5079,7 +5079,7 @@
           <p:cNvPr id="7" name="TextBox 6">
             <a:extLst>
               <a:ext uri="{FF2B5EF4-FFF2-40B4-BE49-F238E27FC236}">
-                <a16:creationId xmlns:a16="http://schemas.microsoft.com/office/drawing/2014/main" id="{659BFDD9-E71B-2F8A-2A67-E8899E0352E7}"/>
+                <a16:creationId xmlns:a16="http://schemas.microsoft.com/office/drawing/2014/main" id="{4D5CABAF-86B1-8F64-5BC6-8366FC540CD4}"/>
               </a:ext>
             </a:extLst>
           </p:cNvPr>
@@ -5122,7 +5122,7 @@
     </p:spTree>
     <p:extLst>
       <p:ext uri="{BB962C8B-B14F-4D97-AF65-F5344CB8AC3E}">
-        <p14:creationId xmlns:p14="http://schemas.microsoft.com/office/powerpoint/2010/main" val="3644622645"/>
+        <p14:creationId xmlns:p14="http://schemas.microsoft.com/office/powerpoint/2010/main" val="4041258475"/>
       </p:ext>
     </p:extLst>
   </p:cSld>
@@ -5162,7 +5162,7 @@
           <p:cNvPr id="2" name="Rectangle 1">
             <a:extLst>
               <a:ext uri="{FF2B5EF4-FFF2-40B4-BE49-F238E27FC236}">
-                <a16:creationId xmlns:a16="http://schemas.microsoft.com/office/drawing/2014/main" id="{C1DDDD02-D965-F734-A136-73BAAE227B92}"/>
+                <a16:creationId xmlns:a16="http://schemas.microsoft.com/office/drawing/2014/main" id="{EC6AE642-A3AC-625E-6883-87854640D451}"/>
               </a:ext>
             </a:extLst>
           </p:cNvPr>
@@ -5230,7 +5230,7 @@
           <p:cNvPr id="3" name="TextBox 2">
             <a:extLst>
               <a:ext uri="{FF2B5EF4-FFF2-40B4-BE49-F238E27FC236}">
-                <a16:creationId xmlns:a16="http://schemas.microsoft.com/office/drawing/2014/main" id="{5EBF69E0-D726-14E1-600A-4C9A5B2205AF}"/>
+                <a16:creationId xmlns:a16="http://schemas.microsoft.com/office/drawing/2014/main" id="{EC5C7B04-FF67-7D31-1D11-FF8F7962C60E}"/>
               </a:ext>
             </a:extLst>
           </p:cNvPr>
@@ -5281,7 +5281,7 @@
           <p:cNvPr id="4" name="TextBox 3">
             <a:extLst>
               <a:ext uri="{FF2B5EF4-FFF2-40B4-BE49-F238E27FC236}">
-                <a16:creationId xmlns:a16="http://schemas.microsoft.com/office/drawing/2014/main" id="{D209DC9F-AF8E-D077-65E3-9A56C192FFD3}"/>
+                <a16:creationId xmlns:a16="http://schemas.microsoft.com/office/drawing/2014/main" id="{2D8138B4-5857-138A-4E16-94A418D2A805}"/>
               </a:ext>
             </a:extLst>
           </p:cNvPr>
@@ -5332,7 +5332,7 @@
           <p:cNvPr id="5" name="TextBox 4">
             <a:extLst>
               <a:ext uri="{FF2B5EF4-FFF2-40B4-BE49-F238E27FC236}">
-                <a16:creationId xmlns:a16="http://schemas.microsoft.com/office/drawing/2014/main" id="{54D5E2C5-F75F-02A6-4B8C-17077848DDC5}"/>
+                <a16:creationId xmlns:a16="http://schemas.microsoft.com/office/drawing/2014/main" id="{E625D866-5123-694B-3095-CC9573C6BD09}"/>
               </a:ext>
             </a:extLst>
           </p:cNvPr>
@@ -5447,7 +5447,7 @@
           <p:cNvPr id="7" name="Graphic 6">
             <a:extLst>
               <a:ext uri="{FF2B5EF4-FFF2-40B4-BE49-F238E27FC236}">
-                <a16:creationId xmlns:a16="http://schemas.microsoft.com/office/drawing/2014/main" id="{D2ABDAFC-86B8-7B98-3D7A-BE57962B1B9B}"/>
+                <a16:creationId xmlns:a16="http://schemas.microsoft.com/office/drawing/2014/main" id="{509C686C-152B-6DC0-9755-96DC029388EA}"/>
               </a:ext>
             </a:extLst>
           </p:cNvPr>
@@ -5483,7 +5483,7 @@
           <p:cNvPr id="8" name="TextBox 7">
             <a:extLst>
               <a:ext uri="{FF2B5EF4-FFF2-40B4-BE49-F238E27FC236}">
-                <a16:creationId xmlns:a16="http://schemas.microsoft.com/office/drawing/2014/main" id="{D5143445-5550-AACF-D490-FA8E5880B3C9}"/>
+                <a16:creationId xmlns:a16="http://schemas.microsoft.com/office/drawing/2014/main" id="{1E79CA3B-C82E-EFF4-CC80-B288A79E1C02}"/>
               </a:ext>
             </a:extLst>
           </p:cNvPr>
@@ -5534,7 +5534,7 @@
           <p:cNvPr id="9" name="TextBox 8">
             <a:extLst>
               <a:ext uri="{FF2B5EF4-FFF2-40B4-BE49-F238E27FC236}">
-                <a16:creationId xmlns:a16="http://schemas.microsoft.com/office/drawing/2014/main" id="{452D0153-2AE2-E6C2-D8CB-CE51238F3795}"/>
+                <a16:creationId xmlns:a16="http://schemas.microsoft.com/office/drawing/2014/main" id="{5E6D10C0-CD1F-6110-7259-A4E957B4B049}"/>
               </a:ext>
             </a:extLst>
           </p:cNvPr>
@@ -5585,7 +5585,7 @@
           <p:cNvPr id="10" name="TextBox 9">
             <a:extLst>
               <a:ext uri="{FF2B5EF4-FFF2-40B4-BE49-F238E27FC236}">
-                <a16:creationId xmlns:a16="http://schemas.microsoft.com/office/drawing/2014/main" id="{8A4A6DD2-7E1D-142C-4761-CDAECD0CA873}"/>
+                <a16:creationId xmlns:a16="http://schemas.microsoft.com/office/drawing/2014/main" id="{46A2A6E1-7759-7E57-AD1F-ED98F4A61E73}"/>
               </a:ext>
             </a:extLst>
           </p:cNvPr>
@@ -5628,7 +5628,7 @@
     </p:spTree>
     <p:extLst>
       <p:ext uri="{BB962C8B-B14F-4D97-AF65-F5344CB8AC3E}">
-        <p14:creationId xmlns:p14="http://schemas.microsoft.com/office/powerpoint/2010/main" val="2869391027"/>
+        <p14:creationId xmlns:p14="http://schemas.microsoft.com/office/powerpoint/2010/main" val="3173979086"/>
       </p:ext>
     </p:extLst>
   </p:cSld>
@@ -5668,7 +5668,7 @@
           <p:cNvPr id="2" name="Rectangle 1">
             <a:extLst>
               <a:ext uri="{FF2B5EF4-FFF2-40B4-BE49-F238E27FC236}">
-                <a16:creationId xmlns:a16="http://schemas.microsoft.com/office/drawing/2014/main" id="{4FD6DC8A-9385-3C9E-53C8-9E15E9DCB421}"/>
+                <a16:creationId xmlns:a16="http://schemas.microsoft.com/office/drawing/2014/main" id="{A0868278-6BD9-356E-2D99-BC1C4D3462E7}"/>
               </a:ext>
             </a:extLst>
           </p:cNvPr>
@@ -5736,7 +5736,7 @@
           <p:cNvPr id="3" name="TextBox 2">
             <a:extLst>
               <a:ext uri="{FF2B5EF4-FFF2-40B4-BE49-F238E27FC236}">
-                <a16:creationId xmlns:a16="http://schemas.microsoft.com/office/drawing/2014/main" id="{2973EA8F-A625-9B9E-FBAC-4557043560B9}"/>
+                <a16:creationId xmlns:a16="http://schemas.microsoft.com/office/drawing/2014/main" id="{99318F07-8702-4AA1-B4F7-7CA73671B80F}"/>
               </a:ext>
             </a:extLst>
           </p:cNvPr>
@@ -5787,7 +5787,7 @@
           <p:cNvPr id="4" name="TextBox 3">
             <a:extLst>
               <a:ext uri="{FF2B5EF4-FFF2-40B4-BE49-F238E27FC236}">
-                <a16:creationId xmlns:a16="http://schemas.microsoft.com/office/drawing/2014/main" id="{1F45003C-D137-B86A-50DB-2E448580CE0B}"/>
+                <a16:creationId xmlns:a16="http://schemas.microsoft.com/office/drawing/2014/main" id="{04D921A3-DC13-2046-2C28-16976CE4BD96}"/>
               </a:ext>
             </a:extLst>
           </p:cNvPr>
@@ -5838,7 +5838,7 @@
           <p:cNvPr id="5" name="TextBox 4">
             <a:extLst>
               <a:ext uri="{FF2B5EF4-FFF2-40B4-BE49-F238E27FC236}">
-                <a16:creationId xmlns:a16="http://schemas.microsoft.com/office/drawing/2014/main" id="{716BCF54-A441-70DE-C71C-BAEB9A34CA3D}"/>
+                <a16:creationId xmlns:a16="http://schemas.microsoft.com/office/drawing/2014/main" id="{B5D6E80A-5C18-207E-F5AF-A7EC3DE039D0}"/>
               </a:ext>
             </a:extLst>
           </p:cNvPr>
@@ -5953,7 +5953,7 @@
           <p:cNvPr id="6" name="TextBox 5">
             <a:extLst>
               <a:ext uri="{FF2B5EF4-FFF2-40B4-BE49-F238E27FC236}">
-                <a16:creationId xmlns:a16="http://schemas.microsoft.com/office/drawing/2014/main" id="{C7EF55FF-9B4A-E159-D471-722BAA349136}"/>
+                <a16:creationId xmlns:a16="http://schemas.microsoft.com/office/drawing/2014/main" id="{502A33B6-82E1-D25E-47A0-122389016AF6}"/>
               </a:ext>
             </a:extLst>
           </p:cNvPr>
@@ -6004,7 +6004,7 @@
           <p:cNvPr id="7" name="TextBox 6">
             <a:extLst>
               <a:ext uri="{FF2B5EF4-FFF2-40B4-BE49-F238E27FC236}">
-                <a16:creationId xmlns:a16="http://schemas.microsoft.com/office/drawing/2014/main" id="{5F9AF39A-18A6-573E-D199-7D99D7AAEC49}"/>
+                <a16:creationId xmlns:a16="http://schemas.microsoft.com/office/drawing/2014/main" id="{094757E4-BC3E-1107-DC6D-277BB267F54E}"/>
               </a:ext>
             </a:extLst>
           </p:cNvPr>
@@ -6047,7 +6047,7 @@
     </p:spTree>
     <p:extLst>
       <p:ext uri="{BB962C8B-B14F-4D97-AF65-F5344CB8AC3E}">
-        <p14:creationId xmlns:p14="http://schemas.microsoft.com/office/powerpoint/2010/main" val="3419317024"/>
+        <p14:creationId xmlns:p14="http://schemas.microsoft.com/office/powerpoint/2010/main" val="4272816682"/>
       </p:ext>
     </p:extLst>
   </p:cSld>
@@ -6087,7 +6087,7 @@
           <p:cNvPr id="2" name="Rectangle 1">
             <a:extLst>
               <a:ext uri="{FF2B5EF4-FFF2-40B4-BE49-F238E27FC236}">
-                <a16:creationId xmlns:a16="http://schemas.microsoft.com/office/drawing/2014/main" id="{4957C315-63F0-2162-1F58-9754E494B0D9}"/>
+                <a16:creationId xmlns:a16="http://schemas.microsoft.com/office/drawing/2014/main" id="{EE0D495B-DCCB-A495-777B-3FBC203657F2}"/>
               </a:ext>
             </a:extLst>
           </p:cNvPr>
@@ -6155,7 +6155,7 @@
           <p:cNvPr id="3" name="TextBox 2">
             <a:extLst>
               <a:ext uri="{FF2B5EF4-FFF2-40B4-BE49-F238E27FC236}">
-                <a16:creationId xmlns:a16="http://schemas.microsoft.com/office/drawing/2014/main" id="{AC15B783-0D3A-2D9F-35DF-006F6A0D506F}"/>
+                <a16:creationId xmlns:a16="http://schemas.microsoft.com/office/drawing/2014/main" id="{FEC80ABA-D3EA-64A9-2FC8-4BBA122E359B}"/>
               </a:ext>
             </a:extLst>
           </p:cNvPr>
@@ -6206,7 +6206,7 @@
           <p:cNvPr id="4" name="TextBox 3">
             <a:extLst>
               <a:ext uri="{FF2B5EF4-FFF2-40B4-BE49-F238E27FC236}">
-                <a16:creationId xmlns:a16="http://schemas.microsoft.com/office/drawing/2014/main" id="{5BF07C45-E9A9-D571-F518-74DC37208160}"/>
+                <a16:creationId xmlns:a16="http://schemas.microsoft.com/office/drawing/2014/main" id="{68972DE4-FE30-6D3A-4C8B-BC04A24CDBDA}"/>
               </a:ext>
             </a:extLst>
           </p:cNvPr>
@@ -6257,7 +6257,7 @@
           <p:cNvPr id="5" name="TextBox 4">
             <a:extLst>
               <a:ext uri="{FF2B5EF4-FFF2-40B4-BE49-F238E27FC236}">
-                <a16:creationId xmlns:a16="http://schemas.microsoft.com/office/drawing/2014/main" id="{00228716-F474-8FE5-226B-3E5F77D63616}"/>
+                <a16:creationId xmlns:a16="http://schemas.microsoft.com/office/drawing/2014/main" id="{6E042108-5697-2F4A-99DA-001180D63035}"/>
               </a:ext>
             </a:extLst>
           </p:cNvPr>
@@ -6372,7 +6372,7 @@
           <p:cNvPr id="6" name="TextBox 5">
             <a:extLst>
               <a:ext uri="{FF2B5EF4-FFF2-40B4-BE49-F238E27FC236}">
-                <a16:creationId xmlns:a16="http://schemas.microsoft.com/office/drawing/2014/main" id="{49BF9C8F-3776-B891-0909-E47DFCF66AC5}"/>
+                <a16:creationId xmlns:a16="http://schemas.microsoft.com/office/drawing/2014/main" id="{F64F3460-6781-EB83-9FD3-77076164787A}"/>
               </a:ext>
             </a:extLst>
           </p:cNvPr>
@@ -6423,7 +6423,7 @@
           <p:cNvPr id="7" name="TextBox 6">
             <a:extLst>
               <a:ext uri="{FF2B5EF4-FFF2-40B4-BE49-F238E27FC236}">
-                <a16:creationId xmlns:a16="http://schemas.microsoft.com/office/drawing/2014/main" id="{47084A2E-ABCA-6E55-4513-D045DA9007AA}"/>
+                <a16:creationId xmlns:a16="http://schemas.microsoft.com/office/drawing/2014/main" id="{9DE03663-13A1-2834-9F92-2A694386DDB1}"/>
               </a:ext>
             </a:extLst>
           </p:cNvPr>
@@ -6466,7 +6466,7 @@
     </p:spTree>
     <p:extLst>
       <p:ext uri="{BB962C8B-B14F-4D97-AF65-F5344CB8AC3E}">
-        <p14:creationId xmlns:p14="http://schemas.microsoft.com/office/powerpoint/2010/main" val="3081593544"/>
+        <p14:creationId xmlns:p14="http://schemas.microsoft.com/office/powerpoint/2010/main" val="3990898077"/>
       </p:ext>
     </p:extLst>
   </p:cSld>
@@ -6506,7 +6506,7 @@
           <p:cNvPr id="2" name="Rectangle 1">
             <a:extLst>
               <a:ext uri="{FF2B5EF4-FFF2-40B4-BE49-F238E27FC236}">
-                <a16:creationId xmlns:a16="http://schemas.microsoft.com/office/drawing/2014/main" id="{572FF034-347A-FE94-3ECC-2E9B52DABF8C}"/>
+                <a16:creationId xmlns:a16="http://schemas.microsoft.com/office/drawing/2014/main" id="{8540C12A-CB0D-458E-B68F-B059FDFEB8E2}"/>
               </a:ext>
             </a:extLst>
           </p:cNvPr>
@@ -6574,7 +6574,7 @@
           <p:cNvPr id="3" name="TextBox 2">
             <a:extLst>
               <a:ext uri="{FF2B5EF4-FFF2-40B4-BE49-F238E27FC236}">
-                <a16:creationId xmlns:a16="http://schemas.microsoft.com/office/drawing/2014/main" id="{AC1BBFAD-4C47-0906-6FAC-2D660E922C31}"/>
+                <a16:creationId xmlns:a16="http://schemas.microsoft.com/office/drawing/2014/main" id="{93671E47-5D94-614A-D018-271A454917B4}"/>
               </a:ext>
             </a:extLst>
           </p:cNvPr>
@@ -6625,7 +6625,7 @@
           <p:cNvPr id="4" name="TextBox 3">
             <a:extLst>
               <a:ext uri="{FF2B5EF4-FFF2-40B4-BE49-F238E27FC236}">
-                <a16:creationId xmlns:a16="http://schemas.microsoft.com/office/drawing/2014/main" id="{8BEB7596-1900-7F98-5E36-5C3BF878085B}"/>
+                <a16:creationId xmlns:a16="http://schemas.microsoft.com/office/drawing/2014/main" id="{01C66635-6806-78A5-E263-C0DBA6C83846}"/>
               </a:ext>
             </a:extLst>
           </p:cNvPr>
@@ -6676,7 +6676,7 @@
           <p:cNvPr id="5" name="TextBox 4">
             <a:extLst>
               <a:ext uri="{FF2B5EF4-FFF2-40B4-BE49-F238E27FC236}">
-                <a16:creationId xmlns:a16="http://schemas.microsoft.com/office/drawing/2014/main" id="{6AB2F42F-1D6D-7318-1A51-857ABC782607}"/>
+                <a16:creationId xmlns:a16="http://schemas.microsoft.com/office/drawing/2014/main" id="{420D9BAD-D153-5F84-77FD-EB4B5F80F572}"/>
               </a:ext>
             </a:extLst>
           </p:cNvPr>
@@ -6759,7 +6759,7 @@
           <p:cNvPr id="6" name="TextBox 5">
             <a:extLst>
               <a:ext uri="{FF2B5EF4-FFF2-40B4-BE49-F238E27FC236}">
-                <a16:creationId xmlns:a16="http://schemas.microsoft.com/office/drawing/2014/main" id="{9732D02C-EE6F-0840-576E-B09ADB7249FC}"/>
+                <a16:creationId xmlns:a16="http://schemas.microsoft.com/office/drawing/2014/main" id="{6B55367B-8E39-1693-F430-49E05845F7DF}"/>
               </a:ext>
             </a:extLst>
           </p:cNvPr>
@@ -6810,7 +6810,7 @@
           <p:cNvPr id="7" name="TextBox 6">
             <a:extLst>
               <a:ext uri="{FF2B5EF4-FFF2-40B4-BE49-F238E27FC236}">
-                <a16:creationId xmlns:a16="http://schemas.microsoft.com/office/drawing/2014/main" id="{04A7D88C-84B2-69C6-AB41-FF7821005812}"/>
+                <a16:creationId xmlns:a16="http://schemas.microsoft.com/office/drawing/2014/main" id="{E0809D51-05F6-BB29-2234-6474CF16A3D7}"/>
               </a:ext>
             </a:extLst>
           </p:cNvPr>
@@ -6853,7 +6853,7 @@
     </p:spTree>
     <p:extLst>
       <p:ext uri="{BB962C8B-B14F-4D97-AF65-F5344CB8AC3E}">
-        <p14:creationId xmlns:p14="http://schemas.microsoft.com/office/powerpoint/2010/main" val="249610831"/>
+        <p14:creationId xmlns:p14="http://schemas.microsoft.com/office/powerpoint/2010/main" val="2169871445"/>
       </p:ext>
     </p:extLst>
   </p:cSld>
@@ -6893,7 +6893,7 @@
           <p:cNvPr id="2" name="Rectangle 1">
             <a:extLst>
               <a:ext uri="{FF2B5EF4-FFF2-40B4-BE49-F238E27FC236}">
-                <a16:creationId xmlns:a16="http://schemas.microsoft.com/office/drawing/2014/main" id="{064042DC-6629-0062-62A9-858A64D5B62B}"/>
+                <a16:creationId xmlns:a16="http://schemas.microsoft.com/office/drawing/2014/main" id="{EE21606C-A925-BCC9-CBAE-6BAB859C9AF2}"/>
               </a:ext>
             </a:extLst>
           </p:cNvPr>
@@ -6961,7 +6961,7 @@
           <p:cNvPr id="3" name="TextBox 2">
             <a:extLst>
               <a:ext uri="{FF2B5EF4-FFF2-40B4-BE49-F238E27FC236}">
-                <a16:creationId xmlns:a16="http://schemas.microsoft.com/office/drawing/2014/main" id="{262988ED-D99B-1260-4584-A75E5D457412}"/>
+                <a16:creationId xmlns:a16="http://schemas.microsoft.com/office/drawing/2014/main" id="{68DEE256-E461-0389-6F8C-1C9C607DF15D}"/>
               </a:ext>
             </a:extLst>
           </p:cNvPr>
@@ -7012,7 +7012,7 @@
           <p:cNvPr id="4" name="TextBox 3">
             <a:extLst>
               <a:ext uri="{FF2B5EF4-FFF2-40B4-BE49-F238E27FC236}">
-                <a16:creationId xmlns:a16="http://schemas.microsoft.com/office/drawing/2014/main" id="{74BD895F-CBD7-A7E8-4025-0A4EA61D70F3}"/>
+                <a16:creationId xmlns:a16="http://schemas.microsoft.com/office/drawing/2014/main" id="{08294639-DD44-1846-DC41-E92E4C74E56A}"/>
               </a:ext>
             </a:extLst>
           </p:cNvPr>
@@ -7063,7 +7063,7 @@
           <p:cNvPr id="5" name="TextBox 4">
             <a:extLst>
               <a:ext uri="{FF2B5EF4-FFF2-40B4-BE49-F238E27FC236}">
-                <a16:creationId xmlns:a16="http://schemas.microsoft.com/office/drawing/2014/main" id="{37CCE5A3-A80B-EAC3-38B5-8770923B80EB}"/>
+                <a16:creationId xmlns:a16="http://schemas.microsoft.com/office/drawing/2014/main" id="{E401A552-15AD-7AAA-ECD3-3EC54D24E82F}"/>
               </a:ext>
             </a:extLst>
           </p:cNvPr>
@@ -7162,7 +7162,7 @@
           <p:cNvPr id="6" name="TextBox 5">
             <a:extLst>
               <a:ext uri="{FF2B5EF4-FFF2-40B4-BE49-F238E27FC236}">
-                <a16:creationId xmlns:a16="http://schemas.microsoft.com/office/drawing/2014/main" id="{DDF4D293-9936-C2D7-4200-8F158E8ED5F4}"/>
+                <a16:creationId xmlns:a16="http://schemas.microsoft.com/office/drawing/2014/main" id="{C3EA672B-ABD4-98AC-FAFC-538D947CEBB8}"/>
               </a:ext>
             </a:extLst>
           </p:cNvPr>
@@ -7213,7 +7213,7 @@
           <p:cNvPr id="7" name="TextBox 6">
             <a:extLst>
               <a:ext uri="{FF2B5EF4-FFF2-40B4-BE49-F238E27FC236}">
-                <a16:creationId xmlns:a16="http://schemas.microsoft.com/office/drawing/2014/main" id="{61B5741F-6872-BAB8-4FCA-814B40D62334}"/>
+                <a16:creationId xmlns:a16="http://schemas.microsoft.com/office/drawing/2014/main" id="{7465B8B7-33CC-2B10-AED8-D1A72F79EE65}"/>
               </a:ext>
             </a:extLst>
           </p:cNvPr>
@@ -7256,7 +7256,7 @@
     </p:spTree>
     <p:extLst>
       <p:ext uri="{BB962C8B-B14F-4D97-AF65-F5344CB8AC3E}">
-        <p14:creationId xmlns:p14="http://schemas.microsoft.com/office/powerpoint/2010/main" val="2098710662"/>
+        <p14:creationId xmlns:p14="http://schemas.microsoft.com/office/powerpoint/2010/main" val="3138742010"/>
       </p:ext>
     </p:extLst>
   </p:cSld>
@@ -7296,7 +7296,7 @@
           <p:cNvPr id="2" name="Rectangle 1">
             <a:extLst>
               <a:ext uri="{FF2B5EF4-FFF2-40B4-BE49-F238E27FC236}">
-                <a16:creationId xmlns:a16="http://schemas.microsoft.com/office/drawing/2014/main" id="{D2316890-915C-3DAE-6A12-31B9B287CBA9}"/>
+                <a16:creationId xmlns:a16="http://schemas.microsoft.com/office/drawing/2014/main" id="{BAE21A3E-FBA7-1B2B-8F38-D68775DA0E3B}"/>
               </a:ext>
             </a:extLst>
           </p:cNvPr>
@@ -7364,7 +7364,7 @@
           <p:cNvPr id="3" name="TextBox 2">
             <a:extLst>
               <a:ext uri="{FF2B5EF4-FFF2-40B4-BE49-F238E27FC236}">
-                <a16:creationId xmlns:a16="http://schemas.microsoft.com/office/drawing/2014/main" id="{8E8A7512-7DDD-E98B-8CCE-748BC26C1DD6}"/>
+                <a16:creationId xmlns:a16="http://schemas.microsoft.com/office/drawing/2014/main" id="{A38EBB95-781C-1701-3DE4-E9762F6FC537}"/>
               </a:ext>
             </a:extLst>
           </p:cNvPr>
@@ -7415,7 +7415,7 @@
           <p:cNvPr id="4" name="TextBox 3">
             <a:extLst>
               <a:ext uri="{FF2B5EF4-FFF2-40B4-BE49-F238E27FC236}">
-                <a16:creationId xmlns:a16="http://schemas.microsoft.com/office/drawing/2014/main" id="{D496291B-98AA-190E-C587-7990BDE4BB30}"/>
+                <a16:creationId xmlns:a16="http://schemas.microsoft.com/office/drawing/2014/main" id="{464D8CD6-E9DF-6ADD-3247-2562149CF0D0}"/>
               </a:ext>
             </a:extLst>
           </p:cNvPr>
@@ -7466,7 +7466,7 @@
           <p:cNvPr id="5" name="TextBox 4">
             <a:extLst>
               <a:ext uri="{FF2B5EF4-FFF2-40B4-BE49-F238E27FC236}">
-                <a16:creationId xmlns:a16="http://schemas.microsoft.com/office/drawing/2014/main" id="{C178EB2C-58B3-2808-9045-3254B56E7C96}"/>
+                <a16:creationId xmlns:a16="http://schemas.microsoft.com/office/drawing/2014/main" id="{B5C4173E-694F-62F9-1BF9-A2D4C48A9F2D}"/>
               </a:ext>
             </a:extLst>
           </p:cNvPr>
@@ -7565,7 +7565,7 @@
           <p:cNvPr id="6" name="TextBox 5">
             <a:extLst>
               <a:ext uri="{FF2B5EF4-FFF2-40B4-BE49-F238E27FC236}">
-                <a16:creationId xmlns:a16="http://schemas.microsoft.com/office/drawing/2014/main" id="{725F87E2-6D88-869C-DBCD-E5F0E53D2FFC}"/>
+                <a16:creationId xmlns:a16="http://schemas.microsoft.com/office/drawing/2014/main" id="{F6E3245D-7CDD-5CA4-23DA-4BD3EAF8A523}"/>
               </a:ext>
             </a:extLst>
           </p:cNvPr>
@@ -7616,7 +7616,7 @@
           <p:cNvPr id="7" name="TextBox 6">
             <a:extLst>
               <a:ext uri="{FF2B5EF4-FFF2-40B4-BE49-F238E27FC236}">
-                <a16:creationId xmlns:a16="http://schemas.microsoft.com/office/drawing/2014/main" id="{903D85A4-797E-F73A-8957-4713E25D88C9}"/>
+                <a16:creationId xmlns:a16="http://schemas.microsoft.com/office/drawing/2014/main" id="{7D1F64BF-9CC8-87C6-BFC7-B390AA15F9BE}"/>
               </a:ext>
             </a:extLst>
           </p:cNvPr>
@@ -7659,7 +7659,7 @@
     </p:spTree>
     <p:extLst>
       <p:ext uri="{BB962C8B-B14F-4D97-AF65-F5344CB8AC3E}">
-        <p14:creationId xmlns:p14="http://schemas.microsoft.com/office/powerpoint/2010/main" val="4029294840"/>
+        <p14:creationId xmlns:p14="http://schemas.microsoft.com/office/powerpoint/2010/main" val="728748594"/>
       </p:ext>
     </p:extLst>
   </p:cSld>
@@ -7699,7 +7699,7 @@
           <p:cNvPr id="2" name="Rectangle 1">
             <a:extLst>
               <a:ext uri="{FF2B5EF4-FFF2-40B4-BE49-F238E27FC236}">
-                <a16:creationId xmlns:a16="http://schemas.microsoft.com/office/drawing/2014/main" id="{64C76063-B888-2255-C156-DE81F88E1851}"/>
+                <a16:creationId xmlns:a16="http://schemas.microsoft.com/office/drawing/2014/main" id="{4960F755-B014-AC18-D925-571A3D37516B}"/>
               </a:ext>
             </a:extLst>
           </p:cNvPr>
@@ -7767,7 +7767,7 @@
           <p:cNvPr id="3" name="TextBox 2">
             <a:extLst>
               <a:ext uri="{FF2B5EF4-FFF2-40B4-BE49-F238E27FC236}">
-                <a16:creationId xmlns:a16="http://schemas.microsoft.com/office/drawing/2014/main" id="{087C55AE-47E2-DC46-0D76-C497F1836471}"/>
+                <a16:creationId xmlns:a16="http://schemas.microsoft.com/office/drawing/2014/main" id="{7673FB19-A7AC-25FB-424E-E7C4FBA2078F}"/>
               </a:ext>
             </a:extLst>
           </p:cNvPr>
@@ -7818,7 +7818,7 @@
           <p:cNvPr id="4" name="TextBox 3">
             <a:extLst>
               <a:ext uri="{FF2B5EF4-FFF2-40B4-BE49-F238E27FC236}">
-                <a16:creationId xmlns:a16="http://schemas.microsoft.com/office/drawing/2014/main" id="{AB4CA396-B401-C5AD-1444-84AB1AD47E2F}"/>
+                <a16:creationId xmlns:a16="http://schemas.microsoft.com/office/drawing/2014/main" id="{DF30CE53-2BD5-B6A2-5FCC-F4CF130B0A39}"/>
               </a:ext>
             </a:extLst>
           </p:cNvPr>
@@ -7869,7 +7869,7 @@
           <p:cNvPr id="5" name="TextBox 4">
             <a:extLst>
               <a:ext uri="{FF2B5EF4-FFF2-40B4-BE49-F238E27FC236}">
-                <a16:creationId xmlns:a16="http://schemas.microsoft.com/office/drawing/2014/main" id="{7ED45161-625C-8BF2-75DE-6FC229081FF8}"/>
+                <a16:creationId xmlns:a16="http://schemas.microsoft.com/office/drawing/2014/main" id="{BA25DB64-41B9-942B-6075-76AB5647060C}"/>
               </a:ext>
             </a:extLst>
           </p:cNvPr>
@@ -7952,7 +7952,7 @@
           <p:cNvPr id="7" name="Graphic 6">
             <a:extLst>
               <a:ext uri="{FF2B5EF4-FFF2-40B4-BE49-F238E27FC236}">
-                <a16:creationId xmlns:a16="http://schemas.microsoft.com/office/drawing/2014/main" id="{B2756A6A-2B87-70AA-681C-0573A7F97D72}"/>
+                <a16:creationId xmlns:a16="http://schemas.microsoft.com/office/drawing/2014/main" id="{F35B4404-B291-7631-93B2-E4380ABBCF34}"/>
               </a:ext>
             </a:extLst>
           </p:cNvPr>
@@ -7988,7 +7988,7 @@
           <p:cNvPr id="8" name="TextBox 7">
             <a:extLst>
               <a:ext uri="{FF2B5EF4-FFF2-40B4-BE49-F238E27FC236}">
-                <a16:creationId xmlns:a16="http://schemas.microsoft.com/office/drawing/2014/main" id="{CB1DA75B-18A7-DCCA-E8FB-DD0F8B8D3A48}"/>
+                <a16:creationId xmlns:a16="http://schemas.microsoft.com/office/drawing/2014/main" id="{61D3CDB1-AFBF-3387-CEF0-DD03ABB5F74C}"/>
               </a:ext>
             </a:extLst>
           </p:cNvPr>
@@ -8039,7 +8039,7 @@
           <p:cNvPr id="9" name="TextBox 8">
             <a:extLst>
               <a:ext uri="{FF2B5EF4-FFF2-40B4-BE49-F238E27FC236}">
-                <a16:creationId xmlns:a16="http://schemas.microsoft.com/office/drawing/2014/main" id="{E3EECDD4-3E19-0980-24A3-E378BFA4C2E2}"/>
+                <a16:creationId xmlns:a16="http://schemas.microsoft.com/office/drawing/2014/main" id="{7A91A42B-C5AA-BAD6-F96E-C32A61B8D7E1}"/>
               </a:ext>
             </a:extLst>
           </p:cNvPr>
@@ -8090,7 +8090,7 @@
           <p:cNvPr id="10" name="TextBox 9">
             <a:extLst>
               <a:ext uri="{FF2B5EF4-FFF2-40B4-BE49-F238E27FC236}">
-                <a16:creationId xmlns:a16="http://schemas.microsoft.com/office/drawing/2014/main" id="{A6ACE19A-0F58-0173-1F7D-B2F3DE197E8B}"/>
+                <a16:creationId xmlns:a16="http://schemas.microsoft.com/office/drawing/2014/main" id="{86B1F984-2271-2248-5B90-1A8DBE7DF287}"/>
               </a:ext>
             </a:extLst>
           </p:cNvPr>
@@ -8133,7 +8133,7 @@
     </p:spTree>
     <p:extLst>
       <p:ext uri="{BB962C8B-B14F-4D97-AF65-F5344CB8AC3E}">
-        <p14:creationId xmlns:p14="http://schemas.microsoft.com/office/powerpoint/2010/main" val="3657365808"/>
+        <p14:creationId xmlns:p14="http://schemas.microsoft.com/office/powerpoint/2010/main" val="3850428002"/>
       </p:ext>
     </p:extLst>
   </p:cSld>
@@ -8173,7 +8173,7 @@
           <p:cNvPr id="2" name="Rectangle 1">
             <a:extLst>
               <a:ext uri="{FF2B5EF4-FFF2-40B4-BE49-F238E27FC236}">
-                <a16:creationId xmlns:a16="http://schemas.microsoft.com/office/drawing/2014/main" id="{9CDC23D5-F49A-65B4-676A-B5DA2C7B9144}"/>
+                <a16:creationId xmlns:a16="http://schemas.microsoft.com/office/drawing/2014/main" id="{83C726B2-FB2C-742A-3D98-B23F0DA59C9C}"/>
               </a:ext>
             </a:extLst>
           </p:cNvPr>
@@ -8241,7 +8241,7 @@
           <p:cNvPr id="3" name="TextBox 2">
             <a:extLst>
               <a:ext uri="{FF2B5EF4-FFF2-40B4-BE49-F238E27FC236}">
-                <a16:creationId xmlns:a16="http://schemas.microsoft.com/office/drawing/2014/main" id="{3E124CE9-C126-A881-B94D-5C630EB014D4}"/>
+                <a16:creationId xmlns:a16="http://schemas.microsoft.com/office/drawing/2014/main" id="{E7D66424-5CB1-82B1-1235-ABCCF9B24B71}"/>
               </a:ext>
             </a:extLst>
           </p:cNvPr>
@@ -8292,7 +8292,7 @@
           <p:cNvPr id="4" name="TextBox 3">
             <a:extLst>
               <a:ext uri="{FF2B5EF4-FFF2-40B4-BE49-F238E27FC236}">
-                <a16:creationId xmlns:a16="http://schemas.microsoft.com/office/drawing/2014/main" id="{E3600C11-DFAB-CE71-E6BF-23D24EF6CBDC}"/>
+                <a16:creationId xmlns:a16="http://schemas.microsoft.com/office/drawing/2014/main" id="{31DF6068-C1A0-5A8B-CF72-30C950D91021}"/>
               </a:ext>
             </a:extLst>
           </p:cNvPr>
@@ -8343,7 +8343,7 @@
           <p:cNvPr id="5" name="TextBox 4">
             <a:extLst>
               <a:ext uri="{FF2B5EF4-FFF2-40B4-BE49-F238E27FC236}">
-                <a16:creationId xmlns:a16="http://schemas.microsoft.com/office/drawing/2014/main" id="{8E81291D-9BA4-4BA8-6121-E6DFB47606A9}"/>
+                <a16:creationId xmlns:a16="http://schemas.microsoft.com/office/drawing/2014/main" id="{86C922CE-7772-4BDE-C5A1-E27AA111C1C2}"/>
               </a:ext>
             </a:extLst>
           </p:cNvPr>
@@ -8442,7 +8442,7 @@
           <p:cNvPr id="6" name="TextBox 5">
             <a:extLst>
               <a:ext uri="{FF2B5EF4-FFF2-40B4-BE49-F238E27FC236}">
-                <a16:creationId xmlns:a16="http://schemas.microsoft.com/office/drawing/2014/main" id="{75D668F1-D447-7DDC-451A-973A917FE400}"/>
+                <a16:creationId xmlns:a16="http://schemas.microsoft.com/office/drawing/2014/main" id="{DBCE14F1-1107-219D-5283-EB27EB5623CE}"/>
               </a:ext>
             </a:extLst>
           </p:cNvPr>
@@ -8493,7 +8493,7 @@
           <p:cNvPr id="7" name="TextBox 6">
             <a:extLst>
               <a:ext uri="{FF2B5EF4-FFF2-40B4-BE49-F238E27FC236}">
-                <a16:creationId xmlns:a16="http://schemas.microsoft.com/office/drawing/2014/main" id="{9C1AB35A-42D7-80DE-AA60-E766B5A032A5}"/>
+                <a16:creationId xmlns:a16="http://schemas.microsoft.com/office/drawing/2014/main" id="{6D956AA2-5CED-0894-56FE-0311C8E7A404}"/>
               </a:ext>
             </a:extLst>
           </p:cNvPr>
@@ -8536,7 +8536,7 @@
     </p:spTree>
     <p:extLst>
       <p:ext uri="{BB962C8B-B14F-4D97-AF65-F5344CB8AC3E}">
-        <p14:creationId xmlns:p14="http://schemas.microsoft.com/office/powerpoint/2010/main" val="4193745221"/>
+        <p14:creationId xmlns:p14="http://schemas.microsoft.com/office/powerpoint/2010/main" val="1056396590"/>
       </p:ext>
     </p:extLst>
   </p:cSld>
@@ -8576,7 +8576,7 @@
           <p:cNvPr id="2" name="Rectangle 1">
             <a:extLst>
               <a:ext uri="{FF2B5EF4-FFF2-40B4-BE49-F238E27FC236}">
-                <a16:creationId xmlns:a16="http://schemas.microsoft.com/office/drawing/2014/main" id="{10A2C604-2EC4-58F7-A0D3-B21780FDCFE9}"/>
+                <a16:creationId xmlns:a16="http://schemas.microsoft.com/office/drawing/2014/main" id="{4D8F1D02-6156-897A-E1F5-772205A654DB}"/>
               </a:ext>
             </a:extLst>
           </p:cNvPr>
@@ -8644,7 +8644,7 @@
           <p:cNvPr id="3" name="TextBox 2">
             <a:extLst>
               <a:ext uri="{FF2B5EF4-FFF2-40B4-BE49-F238E27FC236}">
-                <a16:creationId xmlns:a16="http://schemas.microsoft.com/office/drawing/2014/main" id="{4F4D5307-C430-C823-DB4A-334A2E9325A9}"/>
+                <a16:creationId xmlns:a16="http://schemas.microsoft.com/office/drawing/2014/main" id="{B4BB7CFC-B9E5-83E5-8D49-7F7D3C53C191}"/>
               </a:ext>
             </a:extLst>
           </p:cNvPr>
@@ -8695,7 +8695,7 @@
           <p:cNvPr id="4" name="TextBox 3">
             <a:extLst>
               <a:ext uri="{FF2B5EF4-FFF2-40B4-BE49-F238E27FC236}">
-                <a16:creationId xmlns:a16="http://schemas.microsoft.com/office/drawing/2014/main" id="{42ED8E6E-AF23-6D4A-C00C-51F05C16DD8C}"/>
+                <a16:creationId xmlns:a16="http://schemas.microsoft.com/office/drawing/2014/main" id="{BD369607-F338-62FA-C8A4-60FBB40876E3}"/>
               </a:ext>
             </a:extLst>
           </p:cNvPr>
@@ -8746,7 +8746,7 @@
           <p:cNvPr id="5" name="TextBox 4">
             <a:extLst>
               <a:ext uri="{FF2B5EF4-FFF2-40B4-BE49-F238E27FC236}">
-                <a16:creationId xmlns:a16="http://schemas.microsoft.com/office/drawing/2014/main" id="{719BD5D1-AB48-CFDE-5996-0F4CB0FEC2C0}"/>
+                <a16:creationId xmlns:a16="http://schemas.microsoft.com/office/drawing/2014/main" id="{16DD87A0-3876-F99A-CF49-A2E1E95C4882}"/>
               </a:ext>
             </a:extLst>
           </p:cNvPr>
@@ -8877,7 +8877,7 @@
           <p:cNvPr id="7" name="Graphic 6">
             <a:extLst>
               <a:ext uri="{FF2B5EF4-FFF2-40B4-BE49-F238E27FC236}">
-                <a16:creationId xmlns:a16="http://schemas.microsoft.com/office/drawing/2014/main" id="{01D7EFFB-B54D-E6A2-7570-62F05F452AB6}"/>
+                <a16:creationId xmlns:a16="http://schemas.microsoft.com/office/drawing/2014/main" id="{B56897E5-8EAE-2CDA-F45F-09D0E7D543EE}"/>
               </a:ext>
             </a:extLst>
           </p:cNvPr>
@@ -8913,7 +8913,7 @@
           <p:cNvPr id="8" name="TextBox 7">
             <a:extLst>
               <a:ext uri="{FF2B5EF4-FFF2-40B4-BE49-F238E27FC236}">
-                <a16:creationId xmlns:a16="http://schemas.microsoft.com/office/drawing/2014/main" id="{3C4E33D1-8E5A-FD0D-D568-C5EB04474A9A}"/>
+                <a16:creationId xmlns:a16="http://schemas.microsoft.com/office/drawing/2014/main" id="{DC6E6824-BA77-24C3-9072-E7D1BFB10121}"/>
               </a:ext>
             </a:extLst>
           </p:cNvPr>
@@ -8964,7 +8964,7 @@
           <p:cNvPr id="9" name="TextBox 8">
             <a:extLst>
               <a:ext uri="{FF2B5EF4-FFF2-40B4-BE49-F238E27FC236}">
-                <a16:creationId xmlns:a16="http://schemas.microsoft.com/office/drawing/2014/main" id="{7598914C-8BEB-8269-AB1C-C9658A051212}"/>
+                <a16:creationId xmlns:a16="http://schemas.microsoft.com/office/drawing/2014/main" id="{7D172B21-537F-B6EA-C40F-55E3279A1E1C}"/>
               </a:ext>
             </a:extLst>
           </p:cNvPr>
@@ -9015,7 +9015,7 @@
           <p:cNvPr id="10" name="TextBox 9">
             <a:extLst>
               <a:ext uri="{FF2B5EF4-FFF2-40B4-BE49-F238E27FC236}">
-                <a16:creationId xmlns:a16="http://schemas.microsoft.com/office/drawing/2014/main" id="{1BA58BE2-BCC0-C4EC-EF62-F6D1958D1D2E}"/>
+                <a16:creationId xmlns:a16="http://schemas.microsoft.com/office/drawing/2014/main" id="{9DB1DE38-DB6C-8F8D-62B5-82113606A5C3}"/>
               </a:ext>
             </a:extLst>
           </p:cNvPr>
@@ -9058,7 +9058,7 @@
     </p:spTree>
     <p:extLst>
       <p:ext uri="{BB962C8B-B14F-4D97-AF65-F5344CB8AC3E}">
-        <p14:creationId xmlns:p14="http://schemas.microsoft.com/office/powerpoint/2010/main" val="1269563741"/>
+        <p14:creationId xmlns:p14="http://schemas.microsoft.com/office/powerpoint/2010/main" val="284745217"/>
       </p:ext>
     </p:extLst>
   </p:cSld>
@@ -9098,7 +9098,7 @@
           <p:cNvPr id="2" name="Rectangle 1">
             <a:extLst>
               <a:ext uri="{FF2B5EF4-FFF2-40B4-BE49-F238E27FC236}">
-                <a16:creationId xmlns:a16="http://schemas.microsoft.com/office/drawing/2014/main" id="{4EF67A9B-E68D-7609-38F3-B20BCAB7C57F}"/>
+                <a16:creationId xmlns:a16="http://schemas.microsoft.com/office/drawing/2014/main" id="{B1701066-BC36-8C97-AD6C-0B3A9D67B77A}"/>
               </a:ext>
             </a:extLst>
           </p:cNvPr>
@@ -9166,7 +9166,7 @@
           <p:cNvPr id="3" name="TextBox 2">
             <a:extLst>
               <a:ext uri="{FF2B5EF4-FFF2-40B4-BE49-F238E27FC236}">
-                <a16:creationId xmlns:a16="http://schemas.microsoft.com/office/drawing/2014/main" id="{87B3E6B6-A7C8-7894-55FB-05D15FF6C778}"/>
+                <a16:creationId xmlns:a16="http://schemas.microsoft.com/office/drawing/2014/main" id="{CD67211B-68BD-B6E4-2F98-97D610246A61}"/>
               </a:ext>
             </a:extLst>
           </p:cNvPr>
@@ -9217,7 +9217,7 @@
           <p:cNvPr id="4" name="TextBox 3">
             <a:extLst>
               <a:ext uri="{FF2B5EF4-FFF2-40B4-BE49-F238E27FC236}">
-                <a16:creationId xmlns:a16="http://schemas.microsoft.com/office/drawing/2014/main" id="{B60E332D-7196-81F5-4AA6-E81ED8A9822D}"/>
+                <a16:creationId xmlns:a16="http://schemas.microsoft.com/office/drawing/2014/main" id="{2DD913C1-FDD6-79D4-249B-70BB7C26A4F6}"/>
               </a:ext>
             </a:extLst>
           </p:cNvPr>
@@ -9268,7 +9268,7 @@
           <p:cNvPr id="5" name="TextBox 4">
             <a:extLst>
               <a:ext uri="{FF2B5EF4-FFF2-40B4-BE49-F238E27FC236}">
-                <a16:creationId xmlns:a16="http://schemas.microsoft.com/office/drawing/2014/main" id="{0B5AD68D-9EED-4B87-9C94-F7EAB77BFBDD}"/>
+                <a16:creationId xmlns:a16="http://schemas.microsoft.com/office/drawing/2014/main" id="{8AFA1B90-A37D-6387-53FA-F4DED3A77BF1}"/>
               </a:ext>
             </a:extLst>
           </p:cNvPr>
@@ -9527,7 +9527,7 @@
           <p:cNvPr id="7" name="Graphic 6">
             <a:extLst>
               <a:ext uri="{FF2B5EF4-FFF2-40B4-BE49-F238E27FC236}">
-                <a16:creationId xmlns:a16="http://schemas.microsoft.com/office/drawing/2014/main" id="{73B49655-0D99-B30F-2CF3-0FABFBDBD287}"/>
+                <a16:creationId xmlns:a16="http://schemas.microsoft.com/office/drawing/2014/main" id="{03DE46D1-8A68-E8CE-B27C-9027347BFD14}"/>
               </a:ext>
             </a:extLst>
           </p:cNvPr>
@@ -9563,7 +9563,7 @@
           <p:cNvPr id="8" name="TextBox 7">
             <a:extLst>
               <a:ext uri="{FF2B5EF4-FFF2-40B4-BE49-F238E27FC236}">
-                <a16:creationId xmlns:a16="http://schemas.microsoft.com/office/drawing/2014/main" id="{66B5803D-B8BF-7BE4-7ECB-FF588685E74F}"/>
+                <a16:creationId xmlns:a16="http://schemas.microsoft.com/office/drawing/2014/main" id="{BC629456-EAAD-D08C-0141-2D35864EF75D}"/>
               </a:ext>
             </a:extLst>
           </p:cNvPr>
@@ -9614,7 +9614,7 @@
           <p:cNvPr id="9" name="TextBox 8">
             <a:extLst>
               <a:ext uri="{FF2B5EF4-FFF2-40B4-BE49-F238E27FC236}">
-                <a16:creationId xmlns:a16="http://schemas.microsoft.com/office/drawing/2014/main" id="{99C13883-6A47-DE96-C2B5-9E91BF735B5E}"/>
+                <a16:creationId xmlns:a16="http://schemas.microsoft.com/office/drawing/2014/main" id="{7A6A5075-336B-5893-7D16-D58E5780B503}"/>
               </a:ext>
             </a:extLst>
           </p:cNvPr>
@@ -9665,7 +9665,7 @@
           <p:cNvPr id="10" name="TextBox 9">
             <a:extLst>
               <a:ext uri="{FF2B5EF4-FFF2-40B4-BE49-F238E27FC236}">
-                <a16:creationId xmlns:a16="http://schemas.microsoft.com/office/drawing/2014/main" id="{8DA4F0DB-DE13-6A47-10D0-8764AB0FEE3A}"/>
+                <a16:creationId xmlns:a16="http://schemas.microsoft.com/office/drawing/2014/main" id="{E914040A-6FB5-2600-DBBA-00B5C7AB48CF}"/>
               </a:ext>
             </a:extLst>
           </p:cNvPr>
@@ -9708,7 +9708,7 @@
     </p:spTree>
     <p:extLst>
       <p:ext uri="{BB962C8B-B14F-4D97-AF65-F5344CB8AC3E}">
-        <p14:creationId xmlns:p14="http://schemas.microsoft.com/office/powerpoint/2010/main" val="2745055755"/>
+        <p14:creationId xmlns:p14="http://schemas.microsoft.com/office/powerpoint/2010/main" val="547823131"/>
       </p:ext>
     </p:extLst>
   </p:cSld>
@@ -9748,7 +9748,7 @@
           <p:cNvPr id="2" name="Rectangle 1">
             <a:extLst>
               <a:ext uri="{FF2B5EF4-FFF2-40B4-BE49-F238E27FC236}">
-                <a16:creationId xmlns:a16="http://schemas.microsoft.com/office/drawing/2014/main" id="{64BE9C0D-D422-E6CE-D052-1190B6F2AB11}"/>
+                <a16:creationId xmlns:a16="http://schemas.microsoft.com/office/drawing/2014/main" id="{4238C539-665A-F057-1CB7-D1E890A61608}"/>
               </a:ext>
             </a:extLst>
           </p:cNvPr>
@@ -9816,7 +9816,7 @@
           <p:cNvPr id="3" name="TextBox 2">
             <a:extLst>
               <a:ext uri="{FF2B5EF4-FFF2-40B4-BE49-F238E27FC236}">
-                <a16:creationId xmlns:a16="http://schemas.microsoft.com/office/drawing/2014/main" id="{1575BF68-5842-C543-4D01-5C9F6820BA43}"/>
+                <a16:creationId xmlns:a16="http://schemas.microsoft.com/office/drawing/2014/main" id="{8040A384-FB3B-DC40-604B-D6353A4D6653}"/>
               </a:ext>
             </a:extLst>
           </p:cNvPr>
@@ -9867,7 +9867,7 @@
           <p:cNvPr id="4" name="TextBox 3">
             <a:extLst>
               <a:ext uri="{FF2B5EF4-FFF2-40B4-BE49-F238E27FC236}">
-                <a16:creationId xmlns:a16="http://schemas.microsoft.com/office/drawing/2014/main" id="{1DB4E985-909E-C075-7FE1-10FA6AEAAEF0}"/>
+                <a16:creationId xmlns:a16="http://schemas.microsoft.com/office/drawing/2014/main" id="{60C6D629-7870-C5D1-A845-DC3E65424AD6}"/>
               </a:ext>
             </a:extLst>
           </p:cNvPr>
@@ -9918,7 +9918,7 @@
           <p:cNvPr id="5" name="TextBox 4">
             <a:extLst>
               <a:ext uri="{FF2B5EF4-FFF2-40B4-BE49-F238E27FC236}">
-                <a16:creationId xmlns:a16="http://schemas.microsoft.com/office/drawing/2014/main" id="{ED2FE091-A2B8-B550-DEA7-62404057412C}"/>
+                <a16:creationId xmlns:a16="http://schemas.microsoft.com/office/drawing/2014/main" id="{7C7A3C26-74AC-7CD8-CEA7-52900285A717}"/>
               </a:ext>
             </a:extLst>
           </p:cNvPr>
@@ -10017,7 +10017,7 @@
           <p:cNvPr id="7" name="Graphic 6">
             <a:extLst>
               <a:ext uri="{FF2B5EF4-FFF2-40B4-BE49-F238E27FC236}">
-                <a16:creationId xmlns:a16="http://schemas.microsoft.com/office/drawing/2014/main" id="{0B0ED2A2-29F0-AB3B-F640-AB17BC2CF108}"/>
+                <a16:creationId xmlns:a16="http://schemas.microsoft.com/office/drawing/2014/main" id="{E97A6CC4-848D-9BE3-B9FA-6D55E25031F2}"/>
               </a:ext>
             </a:extLst>
           </p:cNvPr>
@@ -10053,7 +10053,7 @@
           <p:cNvPr id="8" name="TextBox 7">
             <a:extLst>
               <a:ext uri="{FF2B5EF4-FFF2-40B4-BE49-F238E27FC236}">
-                <a16:creationId xmlns:a16="http://schemas.microsoft.com/office/drawing/2014/main" id="{0C988A98-01EF-9F9E-9CC7-ECAF2B3A58FB}"/>
+                <a16:creationId xmlns:a16="http://schemas.microsoft.com/office/drawing/2014/main" id="{BDCF06E9-F003-C501-D93D-911A72F58E3D}"/>
               </a:ext>
             </a:extLst>
           </p:cNvPr>
@@ -10104,7 +10104,7 @@
           <p:cNvPr id="9" name="TextBox 8">
             <a:extLst>
               <a:ext uri="{FF2B5EF4-FFF2-40B4-BE49-F238E27FC236}">
-                <a16:creationId xmlns:a16="http://schemas.microsoft.com/office/drawing/2014/main" id="{60E56053-2BAD-DB52-B40F-584A275212B7}"/>
+                <a16:creationId xmlns:a16="http://schemas.microsoft.com/office/drawing/2014/main" id="{15B48A45-A818-4C38-4718-6F46DF3F2087}"/>
               </a:ext>
             </a:extLst>
           </p:cNvPr>
@@ -10155,7 +10155,7 @@
           <p:cNvPr id="10" name="TextBox 9">
             <a:extLst>
               <a:ext uri="{FF2B5EF4-FFF2-40B4-BE49-F238E27FC236}">
-                <a16:creationId xmlns:a16="http://schemas.microsoft.com/office/drawing/2014/main" id="{A4AC434F-2D85-B068-91AD-D18B26F16180}"/>
+                <a16:creationId xmlns:a16="http://schemas.microsoft.com/office/drawing/2014/main" id="{F14A9529-F121-2BD7-123C-2ABFC5CBEC2F}"/>
               </a:ext>
             </a:extLst>
           </p:cNvPr>
@@ -10198,7 +10198,7 @@
     </p:spTree>
     <p:extLst>
       <p:ext uri="{BB962C8B-B14F-4D97-AF65-F5344CB8AC3E}">
-        <p14:creationId xmlns:p14="http://schemas.microsoft.com/office/powerpoint/2010/main" val="66854295"/>
+        <p14:creationId xmlns:p14="http://schemas.microsoft.com/office/powerpoint/2010/main" val="2743865785"/>
       </p:ext>
     </p:extLst>
   </p:cSld>

</xml_diff>